<commit_message>
Updated the app to indicate the db not connected and retries
</commit_message>
<xml_diff>
--- a/docs/Presentation.pptx
+++ b/docs/Presentation.pptx
@@ -311,7 +311,7 @@
           <a:p>
             <a:fld id="{5BCAD085-E8A6-8845-BD4E-CB4CCA059FC4}" type="datetimeFigureOut">
               <a:rPr lang="en-US" smtClean="0"/>
-              <a:t>5/19/2026</a:t>
+              <a:t>5/20/2026</a:t>
             </a:fld>
             <a:endParaRPr lang="en-US"/>
           </a:p>
@@ -479,7 +479,7 @@
           <a:p>
             <a:fld id="{5BCAD085-E8A6-8845-BD4E-CB4CCA059FC4}" type="datetimeFigureOut">
               <a:rPr lang="en-US" smtClean="0"/>
-              <a:t>5/19/2026</a:t>
+              <a:t>5/20/2026</a:t>
             </a:fld>
             <a:endParaRPr lang="en-US"/>
           </a:p>
@@ -657,7 +657,7 @@
           <a:p>
             <a:fld id="{5BCAD085-E8A6-8845-BD4E-CB4CCA059FC4}" type="datetimeFigureOut">
               <a:rPr lang="en-US" smtClean="0"/>
-              <a:t>5/19/2026</a:t>
+              <a:t>5/20/2026</a:t>
             </a:fld>
             <a:endParaRPr lang="en-US"/>
           </a:p>
@@ -825,7 +825,7 @@
           <a:p>
             <a:fld id="{5BCAD085-E8A6-8845-BD4E-CB4CCA059FC4}" type="datetimeFigureOut">
               <a:rPr lang="en-US" smtClean="0"/>
-              <a:t>5/19/2026</a:t>
+              <a:t>5/20/2026</a:t>
             </a:fld>
             <a:endParaRPr lang="en-US"/>
           </a:p>
@@ -1070,7 +1070,7 @@
           <a:p>
             <a:fld id="{5BCAD085-E8A6-8845-BD4E-CB4CCA059FC4}" type="datetimeFigureOut">
               <a:rPr lang="en-US" smtClean="0"/>
-              <a:t>5/19/2026</a:t>
+              <a:t>5/20/2026</a:t>
             </a:fld>
             <a:endParaRPr lang="en-US"/>
           </a:p>
@@ -1355,7 +1355,7 @@
           <a:p>
             <a:fld id="{5BCAD085-E8A6-8845-BD4E-CB4CCA059FC4}" type="datetimeFigureOut">
               <a:rPr lang="en-US" smtClean="0"/>
-              <a:t>5/19/2026</a:t>
+              <a:t>5/20/2026</a:t>
             </a:fld>
             <a:endParaRPr lang="en-US"/>
           </a:p>
@@ -1774,7 +1774,7 @@
           <a:p>
             <a:fld id="{5BCAD085-E8A6-8845-BD4E-CB4CCA059FC4}" type="datetimeFigureOut">
               <a:rPr lang="en-US" smtClean="0"/>
-              <a:t>5/19/2026</a:t>
+              <a:t>5/20/2026</a:t>
             </a:fld>
             <a:endParaRPr lang="en-US"/>
           </a:p>
@@ -1891,7 +1891,7 @@
           <a:p>
             <a:fld id="{5BCAD085-E8A6-8845-BD4E-CB4CCA059FC4}" type="datetimeFigureOut">
               <a:rPr lang="en-US" smtClean="0"/>
-              <a:t>5/19/2026</a:t>
+              <a:t>5/20/2026</a:t>
             </a:fld>
             <a:endParaRPr lang="en-US"/>
           </a:p>
@@ -1986,7 +1986,7 @@
           <a:p>
             <a:fld id="{5BCAD085-E8A6-8845-BD4E-CB4CCA059FC4}" type="datetimeFigureOut">
               <a:rPr lang="en-US" smtClean="0"/>
-              <a:t>5/19/2026</a:t>
+              <a:t>5/20/2026</a:t>
             </a:fld>
             <a:endParaRPr lang="en-US"/>
           </a:p>
@@ -2261,7 +2261,7 @@
           <a:p>
             <a:fld id="{5BCAD085-E8A6-8845-BD4E-CB4CCA059FC4}" type="datetimeFigureOut">
               <a:rPr lang="en-US" smtClean="0"/>
-              <a:t>5/19/2026</a:t>
+              <a:t>5/20/2026</a:t>
             </a:fld>
             <a:endParaRPr lang="en-US"/>
           </a:p>
@@ -2513,7 +2513,7 @@
           <a:p>
             <a:fld id="{5BCAD085-E8A6-8845-BD4E-CB4CCA059FC4}" type="datetimeFigureOut">
               <a:rPr lang="en-US" smtClean="0"/>
-              <a:t>5/19/2026</a:t>
+              <a:t>5/20/2026</a:t>
             </a:fld>
             <a:endParaRPr lang="en-US"/>
           </a:p>
@@ -2724,7 +2724,7 @@
           <a:p>
             <a:fld id="{5BCAD085-E8A6-8845-BD4E-CB4CCA059FC4}" type="datetimeFigureOut">
               <a:rPr lang="en-US" smtClean="0"/>
-              <a:t>5/19/2026</a:t>
+              <a:t>5/20/2026</a:t>
             </a:fld>
             <a:endParaRPr lang="en-US"/>
           </a:p>
@@ -3088,10 +3088,7 @@
     <p:bg>
       <p:bgPr>
         <a:solidFill>
-          <a:schemeClr val="tx1">
-            <a:lumMod val="75000"/>
-            <a:lumOff val="25000"/>
-          </a:schemeClr>
+          <a:schemeClr val="bg1"/>
         </a:solidFill>
         <a:effectLst/>
       </p:bgPr>
@@ -3118,7 +3115,7 @@
         </p:nvSpPr>
         <p:spPr>
           <a:xfrm>
-            <a:off x="0" y="0"/>
+            <a:off x="305" y="1969532"/>
             <a:ext cx="12191695" cy="3200400"/>
           </a:xfrm>
           <a:prstGeom prst="rect">
@@ -3164,7 +3161,7 @@
         </p:nvSpPr>
         <p:spPr>
           <a:xfrm>
-            <a:off x="914400" y="1097280"/>
+            <a:off x="1066800" y="3026481"/>
             <a:ext cx="10058400" cy="707886"/>
           </a:xfrm>
           <a:prstGeom prst="rect">
@@ -3203,7 +3200,7 @@
         </p:nvSpPr>
         <p:spPr>
           <a:xfrm>
-            <a:off x="914400" y="2560320"/>
+            <a:off x="1066800" y="2560320"/>
             <a:ext cx="10058400" cy="461665"/>
           </a:xfrm>
           <a:prstGeom prst="rect">
@@ -3226,7 +3223,7 @@
               </a:defRPr>
             </a:pPr>
             <a:r>
-              <a:rPr>
+              <a:rPr dirty="0">
                 <a:latin typeface="Aptos Display" panose="020B0004020202020204" pitchFamily="34" charset="0"/>
               </a:rPr>
               <a:t>Database Practice Project</a:t>
@@ -3242,13 +3239,16 @@
         </p:nvSpPr>
         <p:spPr>
           <a:xfrm>
-            <a:off x="914400" y="4114800"/>
+            <a:off x="1066800" y="3898151"/>
             <a:ext cx="10058400" cy="369332"/>
           </a:xfrm>
           <a:prstGeom prst="rect">
             <a:avLst/>
           </a:prstGeom>
           <a:noFill/>
+          <a:ln>
+            <a:noFill/>
+          </a:ln>
         </p:spPr>
         <p:txBody>
           <a:bodyPr wrap="square">
@@ -3268,85 +3268,7 @@
               <a:rPr dirty="0">
                 <a:latin typeface="Aptos Display" panose="020B0004020202020204" pitchFamily="34" charset="0"/>
               </a:rPr>
-              <a:t>Roman Kysliak  |  PI24E Group</a:t>
-            </a:r>
-          </a:p>
-        </p:txBody>
-      </p:sp>
-      <p:sp>
-        <p:nvSpPr>
-          <p:cNvPr id="6" name="TextBox 5"/>
-          <p:cNvSpPr txBox="1"/>
-          <p:nvPr/>
-        </p:nvSpPr>
-        <p:spPr>
-          <a:xfrm>
-            <a:off x="914400" y="4754880"/>
-            <a:ext cx="10058400" cy="338554"/>
-          </a:xfrm>
-          <a:prstGeom prst="rect">
-            <a:avLst/>
-          </a:prstGeom>
-          <a:noFill/>
-        </p:spPr>
-        <p:txBody>
-          <a:bodyPr wrap="square">
-            <a:spAutoFit/>
-          </a:bodyPr>
-          <a:lstStyle/>
-          <a:p>
-            <a:pPr algn="ctr">
-              <a:defRPr sz="1600" b="0">
-                <a:solidFill>
-                  <a:srgbClr val="AED6F1"/>
-                </a:solidFill>
-                <a:latin typeface="Calibri"/>
-              </a:defRPr>
-            </a:pPr>
-            <a:r>
-              <a:rPr dirty="0">
-                <a:latin typeface="Aptos Display" panose="020B0004020202020204" pitchFamily="34" charset="0"/>
-              </a:rPr>
-              <a:t>Vilnius University of Applied Sciences</a:t>
-            </a:r>
-          </a:p>
-        </p:txBody>
-      </p:sp>
-      <p:sp>
-        <p:nvSpPr>
-          <p:cNvPr id="7" name="TextBox 6"/>
-          <p:cNvSpPr txBox="1"/>
-          <p:nvPr/>
-        </p:nvSpPr>
-        <p:spPr>
-          <a:xfrm>
-            <a:off x="914400" y="5303520"/>
-            <a:ext cx="10058400" cy="338554"/>
-          </a:xfrm>
-          <a:prstGeom prst="rect">
-            <a:avLst/>
-          </a:prstGeom>
-          <a:noFill/>
-        </p:spPr>
-        <p:txBody>
-          <a:bodyPr wrap="square">
-            <a:spAutoFit/>
-          </a:bodyPr>
-          <a:lstStyle/>
-          <a:p>
-            <a:pPr algn="ctr">
-              <a:defRPr sz="1600" b="0">
-                <a:solidFill>
-                  <a:srgbClr val="AED6F1"/>
-                </a:solidFill>
-                <a:latin typeface="Calibri"/>
-              </a:defRPr>
-            </a:pPr>
-            <a:r>
-              <a:rPr>
-                <a:latin typeface="Aptos Display" panose="020B0004020202020204" pitchFamily="34" charset="0"/>
-              </a:rPr>
-              <a:t>Faculty of Electronics and Informatics</a:t>
+              <a:t>Roman Kysliak PI24E Group</a:t>
             </a:r>
           </a:p>
         </p:txBody>
@@ -3446,7 +3368,9 @@
           <a:lstStyle/>
           <a:p>
             <a:pPr algn="ctr"/>
-            <a:endParaRPr/>
+            <a:endParaRPr>
+              <a:latin typeface="Aptos Display" panose="020B0004020202020204" pitchFamily="34" charset="0"/>
+            </a:endParaRPr>
           </a:p>
         </p:txBody>
       </p:sp>
@@ -3459,7 +3383,7 @@
         <p:spPr>
           <a:xfrm>
             <a:off x="914400" y="2195466"/>
-            <a:ext cx="10058400" cy="914400"/>
+            <a:ext cx="10058400" cy="830997"/>
           </a:xfrm>
           <a:prstGeom prst="rect">
             <a:avLst/>
@@ -3481,7 +3405,9 @@
               </a:defRPr>
             </a:pPr>
             <a:r>
-              <a:rPr dirty="0"/>
+              <a:rPr dirty="0">
+                <a:latin typeface="Aptos Display" panose="020B0004020202020204" pitchFamily="34" charset="0"/>
+              </a:rPr>
               <a:t>Thank You</a:t>
             </a:r>
           </a:p>
@@ -3518,7 +3444,9 @@
               </a:defRPr>
             </a:pPr>
             <a:r>
-              <a:rPr dirty="0"/>
+              <a:rPr dirty="0">
+                <a:latin typeface="Aptos Display" panose="020B0004020202020204" pitchFamily="34" charset="0"/>
+              </a:rPr>
               <a:t>Questions?</a:t>
             </a:r>
           </a:p>
@@ -3745,7 +3673,7 @@
               </a:defRPr>
             </a:pPr>
             <a:r>
-              <a:rPr>
+              <a:rPr dirty="0">
                 <a:latin typeface="Aptos Display" panose="020B0004020202020204" pitchFamily="34" charset="0"/>
               </a:rPr>
               <a:t>• Small-to-medium logistics operators lack affordable, integrated management software</a:t>
@@ -3764,10 +3692,34 @@
               </a:defRPr>
             </a:pPr>
             <a:r>
-              <a:rPr>
-                <a:latin typeface="Aptos Display" panose="020B0004020202020204" pitchFamily="34" charset="0"/>
-              </a:rPr>
-              <a:t>• Existing commercial solutions (Route4Me, Onfleet, Bringg) require monthly subscriptions and internet connectivity</a:t>
+              <a:rPr dirty="0">
+                <a:latin typeface="Aptos Display" panose="020B0004020202020204" pitchFamily="34" charset="0"/>
+              </a:rPr>
+              <a:t>• Existing commercial solutions (Route4Me, </a:t>
+            </a:r>
+            <a:r>
+              <a:rPr dirty="0" err="1">
+                <a:latin typeface="Aptos Display" panose="020B0004020202020204" pitchFamily="34" charset="0"/>
+              </a:rPr>
+              <a:t>Onfleet</a:t>
+            </a:r>
+            <a:r>
+              <a:rPr dirty="0">
+                <a:latin typeface="Aptos Display" panose="020B0004020202020204" pitchFamily="34" charset="0"/>
+              </a:rPr>
+              <a:t>, </a:t>
+            </a:r>
+            <a:r>
+              <a:rPr dirty="0" err="1">
+                <a:latin typeface="Aptos Display" panose="020B0004020202020204" pitchFamily="34" charset="0"/>
+              </a:rPr>
+              <a:t>Bringg</a:t>
+            </a:r>
+            <a:r>
+              <a:rPr dirty="0">
+                <a:latin typeface="Aptos Display" panose="020B0004020202020204" pitchFamily="34" charset="0"/>
+              </a:rPr>
+              <a:t>) require monthly subscriptions and internet connectivity</a:t>
             </a:r>
           </a:p>
           <a:p>
@@ -3783,10 +3735,34 @@
               </a:defRPr>
             </a:pPr>
             <a:r>
-              <a:rPr>
-                <a:latin typeface="Aptos Display" panose="020B0004020202020204" pitchFamily="34" charset="0"/>
-              </a:rPr>
-              <a:t>• Open-source alternatives (OpenGTS, Traccar) focus only on GPS tracking and lack order management</a:t>
+              <a:rPr dirty="0">
+                <a:latin typeface="Aptos Display" panose="020B0004020202020204" pitchFamily="34" charset="0"/>
+              </a:rPr>
+              <a:t>• Open-source alternatives (</a:t>
+            </a:r>
+            <a:r>
+              <a:rPr dirty="0" err="1">
+                <a:latin typeface="Aptos Display" panose="020B0004020202020204" pitchFamily="34" charset="0"/>
+              </a:rPr>
+              <a:t>OpenGTS</a:t>
+            </a:r>
+            <a:r>
+              <a:rPr dirty="0">
+                <a:latin typeface="Aptos Display" panose="020B0004020202020204" pitchFamily="34" charset="0"/>
+              </a:rPr>
+              <a:t>, </a:t>
+            </a:r>
+            <a:r>
+              <a:rPr dirty="0" err="1">
+                <a:latin typeface="Aptos Display" panose="020B0004020202020204" pitchFamily="34" charset="0"/>
+              </a:rPr>
+              <a:t>Traccar</a:t>
+            </a:r>
+            <a:r>
+              <a:rPr dirty="0">
+                <a:latin typeface="Aptos Display" panose="020B0004020202020204" pitchFamily="34" charset="0"/>
+              </a:rPr>
+              <a:t>) focus only on GPS tracking and lack order management</a:t>
             </a:r>
           </a:p>
           <a:p>
@@ -3802,7 +3778,7 @@
               </a:defRPr>
             </a:pPr>
             <a:r>
-              <a:rPr>
+              <a:rPr dirty="0">
                 <a:latin typeface="Aptos Display" panose="020B0004020202020204" pitchFamily="34" charset="0"/>
               </a:rPr>
               <a:t>• Current workflows rely on fragmented tools: spreadsheets for orders, paper logs for maintenance, phone for dispatching</a:t>
@@ -3821,7 +3797,7 @@
               </a:defRPr>
             </a:pPr>
             <a:r>
-              <a:rPr>
+              <a:rPr dirty="0">
                 <a:latin typeface="Aptos Display" panose="020B0004020202020204" pitchFamily="34" charset="0"/>
               </a:rPr>
               <a:t>• Need for a self-contained, offline-capable desktop application with a robust database backend</a:t>
@@ -4057,59 +4033,13 @@
       </p:sp>
       <p:sp>
         <p:nvSpPr>
-          <p:cNvPr id="6" name="Rectangle 5"/>
-          <p:cNvSpPr/>
-          <p:nvPr/>
-        </p:nvSpPr>
-        <p:spPr>
-          <a:xfrm>
-            <a:off x="731520" y="2560320"/>
-            <a:ext cx="73152" cy="320040"/>
-          </a:xfrm>
-          <a:prstGeom prst="rect">
-            <a:avLst/>
-          </a:prstGeom>
-          <a:solidFill>
-            <a:srgbClr val="1A5276"/>
-          </a:solidFill>
-          <a:ln>
-            <a:noFill/>
-          </a:ln>
-        </p:spPr>
-        <p:style>
-          <a:lnRef idx="1">
-            <a:schemeClr val="accent1"/>
-          </a:lnRef>
-          <a:fillRef idx="3">
-            <a:schemeClr val="accent1"/>
-          </a:fillRef>
-          <a:effectRef idx="2">
-            <a:schemeClr val="accent1"/>
-          </a:effectRef>
-          <a:fontRef idx="minor">
-            <a:schemeClr val="lt1"/>
-          </a:fontRef>
-        </p:style>
-        <p:txBody>
-          <a:bodyPr rtlCol="0" anchor="ctr"/>
-          <a:lstStyle/>
-          <a:p>
-            <a:pPr algn="ctr"/>
-            <a:endParaRPr>
-              <a:latin typeface="Aptos Display" panose="020B0004020202020204" pitchFamily="34" charset="0"/>
-            </a:endParaRPr>
-          </a:p>
-        </p:txBody>
-      </p:sp>
-      <p:sp>
-        <p:nvSpPr>
           <p:cNvPr id="7" name="TextBox 6"/>
           <p:cNvSpPr txBox="1"/>
           <p:nvPr/>
         </p:nvSpPr>
         <p:spPr>
           <a:xfrm>
-            <a:off x="1005840" y="2560320"/>
+            <a:off x="731520" y="2619643"/>
             <a:ext cx="10058400" cy="338554"/>
           </a:xfrm>
           <a:prstGeom prst="rect">
@@ -4142,59 +4072,13 @@
       </p:sp>
       <p:sp>
         <p:nvSpPr>
-          <p:cNvPr id="8" name="Rectangle 7"/>
-          <p:cNvSpPr/>
-          <p:nvPr/>
-        </p:nvSpPr>
-        <p:spPr>
-          <a:xfrm>
-            <a:off x="731520" y="3063239"/>
-            <a:ext cx="73152" cy="320040"/>
-          </a:xfrm>
-          <a:prstGeom prst="rect">
-            <a:avLst/>
-          </a:prstGeom>
-          <a:solidFill>
-            <a:srgbClr val="1A5276"/>
-          </a:solidFill>
-          <a:ln>
-            <a:noFill/>
-          </a:ln>
-        </p:spPr>
-        <p:style>
-          <a:lnRef idx="1">
-            <a:schemeClr val="accent1"/>
-          </a:lnRef>
-          <a:fillRef idx="3">
-            <a:schemeClr val="accent1"/>
-          </a:fillRef>
-          <a:effectRef idx="2">
-            <a:schemeClr val="accent1"/>
-          </a:effectRef>
-          <a:fontRef idx="minor">
-            <a:schemeClr val="lt1"/>
-          </a:fontRef>
-        </p:style>
-        <p:txBody>
-          <a:bodyPr rtlCol="0" anchor="ctr"/>
-          <a:lstStyle/>
-          <a:p>
-            <a:pPr algn="ctr"/>
-            <a:endParaRPr>
-              <a:latin typeface="Aptos Display" panose="020B0004020202020204" pitchFamily="34" charset="0"/>
-            </a:endParaRPr>
-          </a:p>
-        </p:txBody>
-      </p:sp>
-      <p:sp>
-        <p:nvSpPr>
           <p:cNvPr id="9" name="TextBox 8"/>
           <p:cNvSpPr txBox="1"/>
           <p:nvPr/>
         </p:nvSpPr>
         <p:spPr>
           <a:xfrm>
-            <a:off x="1005840" y="3063239"/>
+            <a:off x="731520" y="3122562"/>
             <a:ext cx="10058400" cy="338554"/>
           </a:xfrm>
           <a:prstGeom prst="rect">
@@ -4227,59 +4111,13 @@
       </p:sp>
       <p:sp>
         <p:nvSpPr>
-          <p:cNvPr id="10" name="Rectangle 9"/>
-          <p:cNvSpPr/>
-          <p:nvPr/>
-        </p:nvSpPr>
-        <p:spPr>
-          <a:xfrm>
-            <a:off x="731520" y="3566160"/>
-            <a:ext cx="73152" cy="320040"/>
-          </a:xfrm>
-          <a:prstGeom prst="rect">
-            <a:avLst/>
-          </a:prstGeom>
-          <a:solidFill>
-            <a:srgbClr val="1A5276"/>
-          </a:solidFill>
-          <a:ln>
-            <a:noFill/>
-          </a:ln>
-        </p:spPr>
-        <p:style>
-          <a:lnRef idx="1">
-            <a:schemeClr val="accent1"/>
-          </a:lnRef>
-          <a:fillRef idx="3">
-            <a:schemeClr val="accent1"/>
-          </a:fillRef>
-          <a:effectRef idx="2">
-            <a:schemeClr val="accent1"/>
-          </a:effectRef>
-          <a:fontRef idx="minor">
-            <a:schemeClr val="lt1"/>
-          </a:fontRef>
-        </p:style>
-        <p:txBody>
-          <a:bodyPr rtlCol="0" anchor="ctr"/>
-          <a:lstStyle/>
-          <a:p>
-            <a:pPr algn="ctr"/>
-            <a:endParaRPr>
-              <a:latin typeface="Aptos Display" panose="020B0004020202020204" pitchFamily="34" charset="0"/>
-            </a:endParaRPr>
-          </a:p>
-        </p:txBody>
-      </p:sp>
-      <p:sp>
-        <p:nvSpPr>
           <p:cNvPr id="11" name="TextBox 10"/>
           <p:cNvSpPr txBox="1"/>
           <p:nvPr/>
         </p:nvSpPr>
         <p:spPr>
           <a:xfrm>
-            <a:off x="1005840" y="3566160"/>
+            <a:off x="731520" y="3625483"/>
             <a:ext cx="10058400" cy="338554"/>
           </a:xfrm>
           <a:prstGeom prst="rect">
@@ -4312,59 +4150,13 @@
       </p:sp>
       <p:sp>
         <p:nvSpPr>
-          <p:cNvPr id="12" name="Rectangle 11"/>
-          <p:cNvSpPr/>
-          <p:nvPr/>
-        </p:nvSpPr>
-        <p:spPr>
-          <a:xfrm>
-            <a:off x="731520" y="4069080"/>
-            <a:ext cx="73152" cy="320040"/>
-          </a:xfrm>
-          <a:prstGeom prst="rect">
-            <a:avLst/>
-          </a:prstGeom>
-          <a:solidFill>
-            <a:srgbClr val="1A5276"/>
-          </a:solidFill>
-          <a:ln>
-            <a:noFill/>
-          </a:ln>
-        </p:spPr>
-        <p:style>
-          <a:lnRef idx="1">
-            <a:schemeClr val="accent1"/>
-          </a:lnRef>
-          <a:fillRef idx="3">
-            <a:schemeClr val="accent1"/>
-          </a:fillRef>
-          <a:effectRef idx="2">
-            <a:schemeClr val="accent1"/>
-          </a:effectRef>
-          <a:fontRef idx="minor">
-            <a:schemeClr val="lt1"/>
-          </a:fontRef>
-        </p:style>
-        <p:txBody>
-          <a:bodyPr rtlCol="0" anchor="ctr"/>
-          <a:lstStyle/>
-          <a:p>
-            <a:pPr algn="ctr"/>
-            <a:endParaRPr>
-              <a:latin typeface="Aptos Display" panose="020B0004020202020204" pitchFamily="34" charset="0"/>
-            </a:endParaRPr>
-          </a:p>
-        </p:txBody>
-      </p:sp>
-      <p:sp>
-        <p:nvSpPr>
           <p:cNvPr id="13" name="TextBox 12"/>
           <p:cNvSpPr txBox="1"/>
           <p:nvPr/>
         </p:nvSpPr>
         <p:spPr>
           <a:xfrm>
-            <a:off x="1005840" y="4069080"/>
+            <a:off x="731520" y="4128403"/>
             <a:ext cx="10058400" cy="338554"/>
           </a:xfrm>
           <a:prstGeom prst="rect">
@@ -4397,59 +4189,13 @@
       </p:sp>
       <p:sp>
         <p:nvSpPr>
-          <p:cNvPr id="14" name="Rectangle 13"/>
-          <p:cNvSpPr/>
-          <p:nvPr/>
-        </p:nvSpPr>
-        <p:spPr>
-          <a:xfrm>
-            <a:off x="731520" y="4572000"/>
-            <a:ext cx="73152" cy="320040"/>
-          </a:xfrm>
-          <a:prstGeom prst="rect">
-            <a:avLst/>
-          </a:prstGeom>
-          <a:solidFill>
-            <a:srgbClr val="1A5276"/>
-          </a:solidFill>
-          <a:ln>
-            <a:noFill/>
-          </a:ln>
-        </p:spPr>
-        <p:style>
-          <a:lnRef idx="1">
-            <a:schemeClr val="accent1"/>
-          </a:lnRef>
-          <a:fillRef idx="3">
-            <a:schemeClr val="accent1"/>
-          </a:fillRef>
-          <a:effectRef idx="2">
-            <a:schemeClr val="accent1"/>
-          </a:effectRef>
-          <a:fontRef idx="minor">
-            <a:schemeClr val="lt1"/>
-          </a:fontRef>
-        </p:style>
-        <p:txBody>
-          <a:bodyPr rtlCol="0" anchor="ctr"/>
-          <a:lstStyle/>
-          <a:p>
-            <a:pPr algn="ctr"/>
-            <a:endParaRPr>
-              <a:latin typeface="Aptos Display" panose="020B0004020202020204" pitchFamily="34" charset="0"/>
-            </a:endParaRPr>
-          </a:p>
-        </p:txBody>
-      </p:sp>
-      <p:sp>
-        <p:nvSpPr>
           <p:cNvPr id="15" name="TextBox 14"/>
           <p:cNvSpPr txBox="1"/>
           <p:nvPr/>
         </p:nvSpPr>
         <p:spPr>
           <a:xfrm>
-            <a:off x="1005840" y="4572000"/>
+            <a:off x="731520" y="4631323"/>
             <a:ext cx="10058400" cy="338554"/>
           </a:xfrm>
           <a:prstGeom prst="rect">
@@ -4482,59 +4228,13 @@
       </p:sp>
       <p:sp>
         <p:nvSpPr>
-          <p:cNvPr id="16" name="Rectangle 15"/>
-          <p:cNvSpPr/>
-          <p:nvPr/>
-        </p:nvSpPr>
-        <p:spPr>
-          <a:xfrm>
-            <a:off x="731520" y="5074920"/>
-            <a:ext cx="73152" cy="320040"/>
-          </a:xfrm>
-          <a:prstGeom prst="rect">
-            <a:avLst/>
-          </a:prstGeom>
-          <a:solidFill>
-            <a:srgbClr val="1A5276"/>
-          </a:solidFill>
-          <a:ln>
-            <a:noFill/>
-          </a:ln>
-        </p:spPr>
-        <p:style>
-          <a:lnRef idx="1">
-            <a:schemeClr val="accent1"/>
-          </a:lnRef>
-          <a:fillRef idx="3">
-            <a:schemeClr val="accent1"/>
-          </a:fillRef>
-          <a:effectRef idx="2">
-            <a:schemeClr val="accent1"/>
-          </a:effectRef>
-          <a:fontRef idx="minor">
-            <a:schemeClr val="lt1"/>
-          </a:fontRef>
-        </p:style>
-        <p:txBody>
-          <a:bodyPr rtlCol="0" anchor="ctr"/>
-          <a:lstStyle/>
-          <a:p>
-            <a:pPr algn="ctr"/>
-            <a:endParaRPr>
-              <a:latin typeface="Aptos Display" panose="020B0004020202020204" pitchFamily="34" charset="0"/>
-            </a:endParaRPr>
-          </a:p>
-        </p:txBody>
-      </p:sp>
-      <p:sp>
-        <p:nvSpPr>
           <p:cNvPr id="17" name="TextBox 16"/>
           <p:cNvSpPr txBox="1"/>
           <p:nvPr/>
         </p:nvSpPr>
         <p:spPr>
           <a:xfrm>
-            <a:off x="1005840" y="5074920"/>
+            <a:off x="731520" y="5134243"/>
             <a:ext cx="10058400" cy="338554"/>
           </a:xfrm>
           <a:prstGeom prst="rect">
@@ -5890,10 +5590,16 @@
               </a:defRPr>
             </a:pPr>
             <a:r>
-              <a:rPr>
-                <a:latin typeface="Aptos Display" panose="020B0004020202020204" pitchFamily="34" charset="0"/>
-              </a:rPr>
-              <a:t>InnoDB storage engine, 16 triggers, foreign key enforcement</a:t>
+              <a:rPr lang="en-US" dirty="0">
+                <a:latin typeface="Aptos Display" panose="020B0004020202020204" pitchFamily="34" charset="0"/>
+              </a:rPr>
+              <a:t>MySQL</a:t>
+            </a:r>
+            <a:r>
+              <a:rPr dirty="0">
+                <a:latin typeface="Aptos Display" panose="020B0004020202020204" pitchFamily="34" charset="0"/>
+              </a:rPr>
+              <a:t>, 16 triggers, foreign key enforcement</a:t>
             </a:r>
           </a:p>
         </p:txBody>
@@ -7521,7 +7227,7 @@
         <p:spPr>
           <a:xfrm>
             <a:off x="914400" y="2011680"/>
-            <a:ext cx="2286000" cy="1292662"/>
+            <a:ext cx="2286000" cy="1692771"/>
           </a:xfrm>
           <a:prstGeom prst="rect">
             <a:avLst/>
@@ -7543,29 +7249,67 @@
               </a:defRPr>
             </a:pPr>
             <a:r>
-              <a:rPr>
-                <a:latin typeface="Aptos Display" panose="020B0004020202020204" pitchFamily="34" charset="0"/>
-              </a:rPr>
-              <a:t>Priority-queue algorithm in route.go</a:t>
+              <a:rPr dirty="0">
+                <a:latin typeface="Aptos Display" panose="020B0004020202020204" pitchFamily="34" charset="0"/>
+              </a:rPr>
+              <a:t>Priority-queue algorithm in </a:t>
+            </a:r>
+            <a:r>
+              <a:rPr dirty="0" err="1">
+                <a:latin typeface="Aptos Display" panose="020B0004020202020204" pitchFamily="34" charset="0"/>
+              </a:rPr>
+              <a:t>route.go</a:t>
             </a:r>
             <a:br>
-              <a:rPr>
+              <a:rPr dirty="0">
                 <a:latin typeface="Aptos Display" panose="020B0004020202020204" pitchFamily="34" charset="0"/>
               </a:rPr>
             </a:br>
-            <a:r>
-              <a:rPr>
-                <a:latin typeface="Aptos Display" panose="020B0004020202020204" pitchFamily="34" charset="0"/>
-              </a:rPr>
-              <a:t>Minimizes travel time = distance / speed_limit</a:t>
-            </a:r>
+            <a:endParaRPr lang="en-US" dirty="0">
+              <a:latin typeface="Aptos Display" panose="020B0004020202020204" pitchFamily="34" charset="0"/>
+            </a:endParaRPr>
+          </a:p>
+          <a:p>
+            <a:pPr algn="l">
+              <a:defRPr sz="1300" b="0">
+                <a:solidFill>
+                  <a:srgbClr val="2C3E50"/>
+                </a:solidFill>
+                <a:latin typeface="Calibri"/>
+              </a:defRPr>
+            </a:pPr>
+            <a:r>
+              <a:rPr dirty="0">
+                <a:latin typeface="Aptos Display" panose="020B0004020202020204" pitchFamily="34" charset="0"/>
+              </a:rPr>
+              <a:t>Minimizes travel time = distance / </a:t>
+            </a:r>
+            <a:r>
+              <a:rPr dirty="0" err="1">
+                <a:latin typeface="Aptos Display" panose="020B0004020202020204" pitchFamily="34" charset="0"/>
+              </a:rPr>
+              <a:t>speed_limit</a:t>
+            </a:r>
+            <a:endParaRPr lang="en-US" dirty="0">
+              <a:latin typeface="Aptos Display" panose="020B0004020202020204" pitchFamily="34" charset="0"/>
+            </a:endParaRPr>
+          </a:p>
+          <a:p>
+            <a:pPr algn="l">
+              <a:defRPr sz="1300" b="0">
+                <a:solidFill>
+                  <a:srgbClr val="2C3E50"/>
+                </a:solidFill>
+                <a:latin typeface="Calibri"/>
+              </a:defRPr>
+            </a:pPr>
             <a:br>
-              <a:rPr>
+              <a:rPr dirty="0">
                 <a:latin typeface="Aptos Display" panose="020B0004020202020204" pitchFamily="34" charset="0"/>
               </a:rPr>
             </a:br>
             <a:r>
-              <a:rPr>
+              <a:rPr dirty="0">
                 <a:latin typeface="Aptos Display" panose="020B0004020202020204" pitchFamily="34" charset="0"/>
               </a:rPr>
               <a:t>Returns ordered edge segments for route visualization</a:t>
@@ -7667,7 +7411,7 @@
         <p:spPr>
           <a:xfrm>
             <a:off x="3749040" y="2011680"/>
-            <a:ext cx="2286000" cy="1492716"/>
+            <a:ext cx="2286000" cy="1892826"/>
           </a:xfrm>
           <a:prstGeom prst="rect">
             <a:avLst/>
@@ -7689,29 +7433,67 @@
               </a:defRPr>
             </a:pPr>
             <a:r>
-              <a:rPr>
-                <a:latin typeface="Aptos Display" panose="020B0004020202020204" pitchFamily="34" charset="0"/>
-              </a:rPr>
-              <a:t>Auto-populate system_audit_logs on INSERT/UPDATE/DELETE</a:t>
+              <a:rPr dirty="0">
+                <a:latin typeface="Aptos Display" panose="020B0004020202020204" pitchFamily="34" charset="0"/>
+              </a:rPr>
+              <a:t>Auto-populate </a:t>
+            </a:r>
+            <a:r>
+              <a:rPr dirty="0" err="1">
+                <a:latin typeface="Aptos Display" panose="020B0004020202020204" pitchFamily="34" charset="0"/>
+              </a:rPr>
+              <a:t>system_audit_logs</a:t>
+            </a:r>
+            <a:r>
+              <a:rPr dirty="0">
+                <a:latin typeface="Aptos Display" panose="020B0004020202020204" pitchFamily="34" charset="0"/>
+              </a:rPr>
+              <a:t> on INSERT/UPDATE/DELETE</a:t>
             </a:r>
             <a:br>
-              <a:rPr>
+              <a:rPr dirty="0">
                 <a:latin typeface="Aptos Display" panose="020B0004020202020204" pitchFamily="34" charset="0"/>
               </a:rPr>
             </a:br>
-            <a:r>
-              <a:rPr>
+            <a:endParaRPr lang="en-US" dirty="0">
+              <a:latin typeface="Aptos Display" panose="020B0004020202020204" pitchFamily="34" charset="0"/>
+            </a:endParaRPr>
+          </a:p>
+          <a:p>
+            <a:pPr algn="l">
+              <a:defRPr sz="1300" b="0">
+                <a:solidFill>
+                  <a:srgbClr val="2C3E50"/>
+                </a:solidFill>
+                <a:latin typeface="Calibri"/>
+              </a:defRPr>
+            </a:pPr>
+            <a:r>
+              <a:rPr dirty="0">
                 <a:latin typeface="Aptos Display" panose="020B0004020202020204" pitchFamily="34" charset="0"/>
               </a:rPr>
               <a:t>Covers orders, users, vehicles, nodes, edges, deliveries</a:t>
             </a:r>
             <a:br>
-              <a:rPr>
+              <a:rPr dirty="0">
                 <a:latin typeface="Aptos Display" panose="020B0004020202020204" pitchFamily="34" charset="0"/>
               </a:rPr>
             </a:br>
-            <a:r>
-              <a:rPr>
+            <a:endParaRPr lang="en-US" dirty="0">
+              <a:latin typeface="Aptos Display" panose="020B0004020202020204" pitchFamily="34" charset="0"/>
+            </a:endParaRPr>
+          </a:p>
+          <a:p>
+            <a:pPr algn="l">
+              <a:defRPr sz="1300" b="0">
+                <a:solidFill>
+                  <a:srgbClr val="2C3E50"/>
+                </a:solidFill>
+                <a:latin typeface="Calibri"/>
+              </a:defRPr>
+            </a:pPr>
+            <a:r>
+              <a:rPr dirty="0">
                 <a:latin typeface="Aptos Display" panose="020B0004020202020204" pitchFamily="34" charset="0"/>
               </a:rPr>
               <a:t>Human-readable change descriptions with timestamps</a:t>
@@ -7813,7 +7595,7 @@
         <p:spPr>
           <a:xfrm>
             <a:off x="6583680" y="2011680"/>
-            <a:ext cx="2286000" cy="1492716"/>
+            <a:ext cx="2286000" cy="1892826"/>
           </a:xfrm>
           <a:prstGeom prst="rect">
             <a:avLst/>
@@ -7835,29 +7617,55 @@
               </a:defRPr>
             </a:pPr>
             <a:r>
-              <a:rPr>
+              <a:rPr dirty="0">
                 <a:latin typeface="Aptos Display" panose="020B0004020202020204" pitchFamily="34" charset="0"/>
               </a:rPr>
               <a:t>5 distinct roles with granular permissions</a:t>
             </a:r>
             <a:br>
-              <a:rPr>
+              <a:rPr dirty="0">
                 <a:latin typeface="Aptos Display" panose="020B0004020202020204" pitchFamily="34" charset="0"/>
               </a:rPr>
             </a:br>
-            <a:r>
-              <a:rPr>
+            <a:endParaRPr lang="en-US" dirty="0">
+              <a:latin typeface="Aptos Display" panose="020B0004020202020204" pitchFamily="34" charset="0"/>
+            </a:endParaRPr>
+          </a:p>
+          <a:p>
+            <a:pPr algn="l">
+              <a:defRPr sz="1300" b="0">
+                <a:solidFill>
+                  <a:srgbClr val="2C3E50"/>
+                </a:solidFill>
+                <a:latin typeface="Calibri"/>
+              </a:defRPr>
+            </a:pPr>
+            <a:r>
+              <a:rPr dirty="0">
                 <a:latin typeface="Aptos Display" panose="020B0004020202020204" pitchFamily="34" charset="0"/>
               </a:rPr>
               <a:t>Dual enforcement: backend API checks + frontend UI adaptation</a:t>
             </a:r>
             <a:br>
-              <a:rPr>
+              <a:rPr dirty="0">
                 <a:latin typeface="Aptos Display" panose="020B0004020202020204" pitchFamily="34" charset="0"/>
               </a:rPr>
             </a:br>
-            <a:r>
-              <a:rPr>
+            <a:endParaRPr lang="en-US" dirty="0">
+              <a:latin typeface="Aptos Display" panose="020B0004020202020204" pitchFamily="34" charset="0"/>
+            </a:endParaRPr>
+          </a:p>
+          <a:p>
+            <a:pPr algn="l">
+              <a:defRPr sz="1300" b="0">
+                <a:solidFill>
+                  <a:srgbClr val="2C3E50"/>
+                </a:solidFill>
+                <a:latin typeface="Calibri"/>
+              </a:defRPr>
+            </a:pPr>
+            <a:r>
+              <a:rPr dirty="0">
                 <a:latin typeface="Aptos Display" panose="020B0004020202020204" pitchFamily="34" charset="0"/>
               </a:rPr>
               <a:t>Admin bypass: hardcoded permission override</a:t>
@@ -7942,10 +7750,16 @@
               </a:defRPr>
             </a:pPr>
             <a:r>
-              <a:rPr>
-                <a:latin typeface="Aptos Display" panose="020B0004020202020204" pitchFamily="34" charset="0"/>
-              </a:rPr>
-              <a:t>BCrypt Security</a:t>
+              <a:rPr dirty="0" err="1">
+                <a:latin typeface="Aptos Display" panose="020B0004020202020204" pitchFamily="34" charset="0"/>
+              </a:rPr>
+              <a:t>BCrypt</a:t>
+            </a:r>
+            <a:r>
+              <a:rPr dirty="0">
+                <a:latin typeface="Aptos Display" panose="020B0004020202020204" pitchFamily="34" charset="0"/>
+              </a:rPr>
+              <a:t> Security</a:t>
             </a:r>
           </a:p>
         </p:txBody>
@@ -7959,7 +7773,7 @@
         <p:spPr>
           <a:xfrm>
             <a:off x="9418320" y="2011680"/>
-            <a:ext cx="2286000" cy="1292662"/>
+            <a:ext cx="2286000" cy="1492716"/>
           </a:xfrm>
           <a:prstGeom prst="rect">
             <a:avLst/>
@@ -7981,29 +7795,79 @@
               </a:defRPr>
             </a:pPr>
             <a:r>
-              <a:rPr>
-                <a:latin typeface="Aptos Display" panose="020B0004020202020204" pitchFamily="34" charset="0"/>
-              </a:rPr>
-              <a:t>Passwords hashed with cost factor 10</a:t>
+              <a:rPr dirty="0">
+                <a:latin typeface="Aptos Display" panose="020B0004020202020204" pitchFamily="34" charset="0"/>
+              </a:rPr>
+              <a:t>Passwords</a:t>
+            </a:r>
+            <a:r>
+              <a:rPr lang="en-US" dirty="0">
+                <a:latin typeface="Aptos Display" panose="020B0004020202020204" pitchFamily="34" charset="0"/>
+              </a:rPr>
+              <a:t> are properly</a:t>
+            </a:r>
+            <a:r>
+              <a:rPr dirty="0">
+                <a:latin typeface="Aptos Display" panose="020B0004020202020204" pitchFamily="34" charset="0"/>
+              </a:rPr>
+              <a:t> hashed</a:t>
             </a:r>
             <a:br>
-              <a:rPr>
+              <a:rPr dirty="0">
                 <a:latin typeface="Aptos Display" panose="020B0004020202020204" pitchFamily="34" charset="0"/>
               </a:rPr>
             </a:br>
-            <a:r>
-              <a:rPr>
-                <a:latin typeface="Aptos Display" panose="020B0004020202020204" pitchFamily="34" charset="0"/>
-              </a:rPr>
-              <a:t>Go golang.org/x/crypto/bcrypt library</a:t>
+            <a:endParaRPr lang="en-US" dirty="0">
+              <a:latin typeface="Aptos Display" panose="020B0004020202020204" pitchFamily="34" charset="0"/>
+            </a:endParaRPr>
+          </a:p>
+          <a:p>
+            <a:pPr algn="l">
+              <a:defRPr sz="1300" b="0">
+                <a:solidFill>
+                  <a:srgbClr val="2C3E50"/>
+                </a:solidFill>
+                <a:latin typeface="Calibri"/>
+              </a:defRPr>
+            </a:pPr>
+            <a:r>
+              <a:rPr dirty="0">
+                <a:latin typeface="Aptos Display" panose="020B0004020202020204" pitchFamily="34" charset="0"/>
+              </a:rPr>
+              <a:t>Go golang.org/x/crypto/</a:t>
+            </a:r>
+            <a:r>
+              <a:rPr dirty="0" err="1">
+                <a:latin typeface="Aptos Display" panose="020B0004020202020204" pitchFamily="34" charset="0"/>
+              </a:rPr>
+              <a:t>bcrypt</a:t>
+            </a:r>
+            <a:r>
+              <a:rPr dirty="0">
+                <a:latin typeface="Aptos Display" panose="020B0004020202020204" pitchFamily="34" charset="0"/>
+              </a:rPr>
+              <a:t> library</a:t>
             </a:r>
             <a:br>
-              <a:rPr>
+              <a:rPr dirty="0">
                 <a:latin typeface="Aptos Display" panose="020B0004020202020204" pitchFamily="34" charset="0"/>
               </a:rPr>
             </a:br>
-            <a:r>
-              <a:rPr>
+            <a:endParaRPr lang="en-US" dirty="0">
+              <a:latin typeface="Aptos Display" panose="020B0004020202020204" pitchFamily="34" charset="0"/>
+            </a:endParaRPr>
+          </a:p>
+          <a:p>
+            <a:pPr algn="l">
+              <a:defRPr sz="1300" b="0">
+                <a:solidFill>
+                  <a:srgbClr val="2C3E50"/>
+                </a:solidFill>
+                <a:latin typeface="Calibri"/>
+              </a:defRPr>
+            </a:pPr>
+            <a:r>
+              <a:rPr dirty="0">
                 <a:latin typeface="Aptos Display" panose="020B0004020202020204" pitchFamily="34" charset="0"/>
               </a:rPr>
               <a:t>Protects credentials even if database is compromised</a:t>
@@ -8200,45 +8064,149 @@
       </p:sp>
       <p:sp>
         <p:nvSpPr>
-          <p:cNvPr id="5" name="Rectangle 4"/>
-          <p:cNvSpPr/>
-          <p:nvPr/>
-        </p:nvSpPr>
-        <p:spPr>
-          <a:xfrm>
-            <a:off x="731520" y="1920240"/>
-            <a:ext cx="54864" cy="320040"/>
-          </a:xfrm>
-          <a:prstGeom prst="rect">
-            <a:avLst/>
-          </a:prstGeom>
-          <a:solidFill>
-            <a:srgbClr val="1A5276"/>
-          </a:solidFill>
-          <a:ln>
-            <a:noFill/>
-          </a:ln>
-        </p:spPr>
-        <p:style>
-          <a:lnRef idx="1">
-            <a:schemeClr val="accent1"/>
-          </a:lnRef>
-          <a:fillRef idx="3">
-            <a:schemeClr val="accent1"/>
-          </a:fillRef>
-          <a:effectRef idx="2">
-            <a:schemeClr val="accent1"/>
-          </a:effectRef>
-          <a:fontRef idx="minor">
-            <a:schemeClr val="lt1"/>
-          </a:fontRef>
-        </p:style>
-        <p:txBody>
-          <a:bodyPr rtlCol="0" anchor="ctr"/>
-          <a:lstStyle/>
-          <a:p>
-            <a:pPr algn="ctr"/>
-            <a:endParaRPr>
+          <p:cNvPr id="6" name="TextBox 5"/>
+          <p:cNvSpPr txBox="1"/>
+          <p:nvPr/>
+        </p:nvSpPr>
+        <p:spPr>
+          <a:xfrm>
+            <a:off x="731520" y="1919316"/>
+            <a:ext cx="5029200" cy="292388"/>
+          </a:xfrm>
+          <a:prstGeom prst="rect">
+            <a:avLst/>
+          </a:prstGeom>
+          <a:noFill/>
+        </p:spPr>
+        <p:txBody>
+          <a:bodyPr wrap="square">
+            <a:spAutoFit/>
+          </a:bodyPr>
+          <a:lstStyle/>
+          <a:p>
+            <a:pPr algn="l">
+              <a:defRPr sz="1300" b="0">
+                <a:solidFill>
+                  <a:srgbClr val="2C3E50"/>
+                </a:solidFill>
+                <a:latin typeface="Calibri"/>
+              </a:defRPr>
+            </a:pPr>
+            <a:r>
+              <a:rPr dirty="0">
+                <a:latin typeface="Aptos Display" panose="020B0004020202020204" pitchFamily="34" charset="0"/>
+              </a:rPr>
+              <a:t>3 basic queries — order status, vehicle availability, driver deliveries</a:t>
+            </a:r>
+          </a:p>
+        </p:txBody>
+      </p:sp>
+      <p:sp>
+        <p:nvSpPr>
+          <p:cNvPr id="8" name="TextBox 7"/>
+          <p:cNvSpPr txBox="1"/>
+          <p:nvPr/>
+        </p:nvSpPr>
+        <p:spPr>
+          <a:xfrm>
+            <a:off x="731520" y="2376516"/>
+            <a:ext cx="5029200" cy="492443"/>
+          </a:xfrm>
+          <a:prstGeom prst="rect">
+            <a:avLst/>
+          </a:prstGeom>
+          <a:noFill/>
+        </p:spPr>
+        <p:txBody>
+          <a:bodyPr wrap="square">
+            <a:spAutoFit/>
+          </a:bodyPr>
+          <a:lstStyle/>
+          <a:p>
+            <a:pPr algn="l">
+              <a:defRPr sz="1300" b="0">
+                <a:solidFill>
+                  <a:srgbClr val="2C3E50"/>
+                </a:solidFill>
+                <a:latin typeface="Calibri"/>
+              </a:defRPr>
+            </a:pPr>
+            <a:r>
+              <a:rPr dirty="0">
+                <a:latin typeface="Aptos Display" panose="020B0004020202020204" pitchFamily="34" charset="0"/>
+              </a:rPr>
+              <a:t>5 SUBSTRING/date queries — email domains, order years, date arithmetic</a:t>
+            </a:r>
+          </a:p>
+        </p:txBody>
+      </p:sp>
+      <p:sp>
+        <p:nvSpPr>
+          <p:cNvPr id="10" name="TextBox 9"/>
+          <p:cNvSpPr txBox="1"/>
+          <p:nvPr/>
+        </p:nvSpPr>
+        <p:spPr>
+          <a:xfrm>
+            <a:off x="731520" y="2833716"/>
+            <a:ext cx="5029200" cy="292388"/>
+          </a:xfrm>
+          <a:prstGeom prst="rect">
+            <a:avLst/>
+          </a:prstGeom>
+          <a:noFill/>
+        </p:spPr>
+        <p:txBody>
+          <a:bodyPr wrap="square">
+            <a:spAutoFit/>
+          </a:bodyPr>
+          <a:lstStyle/>
+          <a:p>
+            <a:pPr algn="l">
+              <a:defRPr sz="1300" b="0">
+                <a:solidFill>
+                  <a:srgbClr val="2C3E50"/>
+                </a:solidFill>
+                <a:latin typeface="Calibri"/>
+              </a:defRPr>
+            </a:pPr>
+            <a:r>
+              <a:rPr dirty="0">
+                <a:latin typeface="Aptos Display" panose="020B0004020202020204" pitchFamily="34" charset="0"/>
+              </a:rPr>
+              <a:t>6 two-table JOINs — </a:t>
+            </a:r>
+            <a:r>
+              <a:rPr dirty="0" err="1">
+                <a:latin typeface="Aptos Display" panose="020B0004020202020204" pitchFamily="34" charset="0"/>
+              </a:rPr>
+              <a:t>orders+customers</a:t>
+            </a:r>
+            <a:r>
+              <a:rPr dirty="0">
+                <a:latin typeface="Aptos Display" panose="020B0004020202020204" pitchFamily="34" charset="0"/>
+              </a:rPr>
+              <a:t>, </a:t>
+            </a:r>
+            <a:r>
+              <a:rPr dirty="0" err="1">
+                <a:latin typeface="Aptos Display" panose="020B0004020202020204" pitchFamily="34" charset="0"/>
+              </a:rPr>
+              <a:t>vehicles+types</a:t>
+            </a:r>
+            <a:r>
+              <a:rPr dirty="0">
+                <a:latin typeface="Aptos Display" panose="020B0004020202020204" pitchFamily="34" charset="0"/>
+              </a:rPr>
+              <a:t>, </a:t>
+            </a:r>
+            <a:r>
+              <a:rPr dirty="0" err="1">
+                <a:latin typeface="Aptos Display" panose="020B0004020202020204" pitchFamily="34" charset="0"/>
+              </a:rPr>
+              <a:t>staff+users</a:t>
+            </a:r>
+            <a:endParaRPr dirty="0">
               <a:latin typeface="Aptos Display" panose="020B0004020202020204" pitchFamily="34" charset="0"/>
             </a:endParaRPr>
           </a:p>
@@ -8246,14 +8214,14 @@
       </p:sp>
       <p:sp>
         <p:nvSpPr>
-          <p:cNvPr id="6" name="TextBox 5"/>
+          <p:cNvPr id="12" name="TextBox 11"/>
           <p:cNvSpPr txBox="1"/>
           <p:nvPr/>
         </p:nvSpPr>
         <p:spPr>
           <a:xfrm>
-            <a:off x="1005840" y="1920240"/>
-            <a:ext cx="5029200" cy="292388"/>
+            <a:off x="731520" y="3290916"/>
+            <a:ext cx="5029200" cy="492443"/>
           </a:xfrm>
           <a:prstGeom prst="rect">
             <a:avLst/>
@@ -8278,67 +8246,21 @@
               <a:rPr>
                 <a:latin typeface="Aptos Display" panose="020B0004020202020204" pitchFamily="34" charset="0"/>
               </a:rPr>
-              <a:t>3 basic queries — order status, vehicle availability, driver deliveries</a:t>
-            </a:r>
-          </a:p>
-        </p:txBody>
-      </p:sp>
-      <p:sp>
-        <p:nvSpPr>
-          <p:cNvPr id="7" name="Rectangle 6"/>
-          <p:cNvSpPr/>
-          <p:nvPr/>
-        </p:nvSpPr>
-        <p:spPr>
-          <a:xfrm>
-            <a:off x="731520" y="2377440"/>
-            <a:ext cx="54864" cy="320040"/>
-          </a:xfrm>
-          <a:prstGeom prst="rect">
-            <a:avLst/>
-          </a:prstGeom>
-          <a:solidFill>
-            <a:srgbClr val="1A5276"/>
-          </a:solidFill>
-          <a:ln>
-            <a:noFill/>
-          </a:ln>
-        </p:spPr>
-        <p:style>
-          <a:lnRef idx="1">
-            <a:schemeClr val="accent1"/>
-          </a:lnRef>
-          <a:fillRef idx="3">
-            <a:schemeClr val="accent1"/>
-          </a:fillRef>
-          <a:effectRef idx="2">
-            <a:schemeClr val="accent1"/>
-          </a:effectRef>
-          <a:fontRef idx="minor">
-            <a:schemeClr val="lt1"/>
-          </a:fontRef>
-        </p:style>
-        <p:txBody>
-          <a:bodyPr rtlCol="0" anchor="ctr"/>
-          <a:lstStyle/>
-          <a:p>
-            <a:pPr algn="ctr"/>
-            <a:endParaRPr>
-              <a:latin typeface="Aptos Display" panose="020B0004020202020204" pitchFamily="34" charset="0"/>
-            </a:endParaRPr>
-          </a:p>
-        </p:txBody>
-      </p:sp>
-      <p:sp>
-        <p:nvSpPr>
-          <p:cNvPr id="8" name="TextBox 7"/>
+              <a:t>6 multi-table JOINs — routes+drivers+vehicles, orders+customers+nodes</a:t>
+            </a:r>
+          </a:p>
+        </p:txBody>
+      </p:sp>
+      <p:sp>
+        <p:nvSpPr>
+          <p:cNvPr id="14" name="TextBox 13"/>
           <p:cNvSpPr txBox="1"/>
           <p:nvPr/>
         </p:nvSpPr>
         <p:spPr>
           <a:xfrm>
-            <a:off x="1005840" y="2377440"/>
-            <a:ext cx="5029200" cy="492443"/>
+            <a:off x="731520" y="3748115"/>
+            <a:ext cx="5029200" cy="292388"/>
           </a:xfrm>
           <a:prstGeom prst="rect">
             <a:avLst/>
@@ -8363,66 +8285,20 @@
               <a:rPr>
                 <a:latin typeface="Aptos Display" panose="020B0004020202020204" pitchFamily="34" charset="0"/>
               </a:rPr>
-              <a:t>5 SUBSTRING/date queries — email domains, order years, date arithmetic</a:t>
-            </a:r>
-          </a:p>
-        </p:txBody>
-      </p:sp>
-      <p:sp>
-        <p:nvSpPr>
-          <p:cNvPr id="9" name="Rectangle 8"/>
-          <p:cNvSpPr/>
-          <p:nvPr/>
-        </p:nvSpPr>
-        <p:spPr>
-          <a:xfrm>
-            <a:off x="731520" y="2834640"/>
-            <a:ext cx="54864" cy="320040"/>
-          </a:xfrm>
-          <a:prstGeom prst="rect">
-            <a:avLst/>
-          </a:prstGeom>
-          <a:solidFill>
-            <a:srgbClr val="1A5276"/>
-          </a:solidFill>
-          <a:ln>
-            <a:noFill/>
-          </a:ln>
-        </p:spPr>
-        <p:style>
-          <a:lnRef idx="1">
-            <a:schemeClr val="accent1"/>
-          </a:lnRef>
-          <a:fillRef idx="3">
-            <a:schemeClr val="accent1"/>
-          </a:fillRef>
-          <a:effectRef idx="2">
-            <a:schemeClr val="accent1"/>
-          </a:effectRef>
-          <a:fontRef idx="minor">
-            <a:schemeClr val="lt1"/>
-          </a:fontRef>
-        </p:style>
-        <p:txBody>
-          <a:bodyPr rtlCol="0" anchor="ctr"/>
-          <a:lstStyle/>
-          <a:p>
-            <a:pPr algn="ctr"/>
-            <a:endParaRPr>
-              <a:latin typeface="Aptos Display" panose="020B0004020202020204" pitchFamily="34" charset="0"/>
-            </a:endParaRPr>
-          </a:p>
-        </p:txBody>
-      </p:sp>
-      <p:sp>
-        <p:nvSpPr>
-          <p:cNvPr id="10" name="TextBox 9"/>
+              <a:t>10 complex queries — subqueries, EXISTS, window functions (RANK)</a:t>
+            </a:r>
+          </a:p>
+        </p:txBody>
+      </p:sp>
+      <p:sp>
+        <p:nvSpPr>
+          <p:cNvPr id="16" name="TextBox 15"/>
           <p:cNvSpPr txBox="1"/>
           <p:nvPr/>
         </p:nvSpPr>
         <p:spPr>
           <a:xfrm>
-            <a:off x="1005840" y="2834640"/>
+            <a:off x="731520" y="4205316"/>
             <a:ext cx="5029200" cy="292388"/>
           </a:xfrm>
           <a:prstGeom prst="rect">
@@ -8448,67 +8324,21 @@
               <a:rPr>
                 <a:latin typeface="Aptos Display" panose="020B0004020202020204" pitchFamily="34" charset="0"/>
               </a:rPr>
-              <a:t>6 two-table JOINs — orders+customers, vehicles+types, staff+users</a:t>
-            </a:r>
-          </a:p>
-        </p:txBody>
-      </p:sp>
-      <p:sp>
-        <p:nvSpPr>
-          <p:cNvPr id="11" name="Rectangle 10"/>
-          <p:cNvSpPr/>
-          <p:nvPr/>
-        </p:nvSpPr>
-        <p:spPr>
-          <a:xfrm>
-            <a:off x="731520" y="3291840"/>
-            <a:ext cx="54864" cy="320040"/>
-          </a:xfrm>
-          <a:prstGeom prst="rect">
-            <a:avLst/>
-          </a:prstGeom>
-          <a:solidFill>
-            <a:srgbClr val="1A5276"/>
-          </a:solidFill>
-          <a:ln>
-            <a:noFill/>
-          </a:ln>
-        </p:spPr>
-        <p:style>
-          <a:lnRef idx="1">
-            <a:schemeClr val="accent1"/>
-          </a:lnRef>
-          <a:fillRef idx="3">
-            <a:schemeClr val="accent1"/>
-          </a:fillRef>
-          <a:effectRef idx="2">
-            <a:schemeClr val="accent1"/>
-          </a:effectRef>
-          <a:fontRef idx="minor">
-            <a:schemeClr val="lt1"/>
-          </a:fontRef>
-        </p:style>
-        <p:txBody>
-          <a:bodyPr rtlCol="0" anchor="ctr"/>
-          <a:lstStyle/>
-          <a:p>
-            <a:pPr algn="ctr"/>
-            <a:endParaRPr>
-              <a:latin typeface="Aptos Display" panose="020B0004020202020204" pitchFamily="34" charset="0"/>
-            </a:endParaRPr>
-          </a:p>
-        </p:txBody>
-      </p:sp>
-      <p:sp>
-        <p:nvSpPr>
-          <p:cNvPr id="12" name="TextBox 11"/>
+              <a:t>16 triggers — auto-audit on all CRUD operations</a:t>
+            </a:r>
+          </a:p>
+        </p:txBody>
+      </p:sp>
+      <p:sp>
+        <p:nvSpPr>
+          <p:cNvPr id="18" name="TextBox 17"/>
           <p:cNvSpPr txBox="1"/>
           <p:nvPr/>
         </p:nvSpPr>
         <p:spPr>
           <a:xfrm>
-            <a:off x="1005840" y="3291840"/>
-            <a:ext cx="5029200" cy="492443"/>
+            <a:off x="731520" y="4662516"/>
+            <a:ext cx="5029200" cy="292388"/>
           </a:xfrm>
           <a:prstGeom prst="rect">
             <a:avLst/>
@@ -8533,67 +8363,21 @@
               <a:rPr>
                 <a:latin typeface="Aptos Display" panose="020B0004020202020204" pitchFamily="34" charset="0"/>
               </a:rPr>
-              <a:t>6 multi-table JOINs — routes+drivers+vehicles, orders+customers+nodes</a:t>
-            </a:r>
-          </a:p>
-        </p:txBody>
-      </p:sp>
-      <p:sp>
-        <p:nvSpPr>
-          <p:cNvPr id="13" name="Rectangle 12"/>
-          <p:cNvSpPr/>
-          <p:nvPr/>
-        </p:nvSpPr>
-        <p:spPr>
-          <a:xfrm>
-            <a:off x="731520" y="3749039"/>
-            <a:ext cx="54864" cy="320040"/>
-          </a:xfrm>
-          <a:prstGeom prst="rect">
-            <a:avLst/>
-          </a:prstGeom>
-          <a:solidFill>
-            <a:srgbClr val="1A5276"/>
-          </a:solidFill>
-          <a:ln>
-            <a:noFill/>
-          </a:ln>
-        </p:spPr>
-        <p:style>
-          <a:lnRef idx="1">
-            <a:schemeClr val="accent1"/>
-          </a:lnRef>
-          <a:fillRef idx="3">
-            <a:schemeClr val="accent1"/>
-          </a:fillRef>
-          <a:effectRef idx="2">
-            <a:schemeClr val="accent1"/>
-          </a:effectRef>
-          <a:fontRef idx="minor">
-            <a:schemeClr val="lt1"/>
-          </a:fontRef>
-        </p:style>
-        <p:txBody>
-          <a:bodyPr rtlCol="0" anchor="ctr"/>
-          <a:lstStyle/>
-          <a:p>
-            <a:pPr algn="ctr"/>
-            <a:endParaRPr>
-              <a:latin typeface="Aptos Display" panose="020B0004020202020204" pitchFamily="34" charset="0"/>
-            </a:endParaRPr>
-          </a:p>
-        </p:txBody>
-      </p:sp>
-      <p:sp>
-        <p:nvSpPr>
-          <p:cNvPr id="14" name="TextBox 13"/>
+              <a:t>All queries executable from docs/db_schema/queries.sql</a:t>
+            </a:r>
+          </a:p>
+        </p:txBody>
+      </p:sp>
+      <p:sp>
+        <p:nvSpPr>
+          <p:cNvPr id="19" name="TextBox 18"/>
           <p:cNvSpPr txBox="1"/>
           <p:nvPr/>
         </p:nvSpPr>
         <p:spPr>
           <a:xfrm>
-            <a:off x="1005840" y="3749039"/>
-            <a:ext cx="5029200" cy="292388"/>
+            <a:off x="6583680" y="1371600"/>
+            <a:ext cx="5029200" cy="430887"/>
           </a:xfrm>
           <a:prstGeom prst="rect">
             <a:avLst/>
@@ -8607,9 +8391,9 @@
           <a:lstStyle/>
           <a:p>
             <a:pPr algn="l">
-              <a:defRPr sz="1300" b="0">
-                <a:solidFill>
-                  <a:srgbClr val="2C3E50"/>
+              <a:defRPr sz="2200" b="1">
+                <a:solidFill>
+                  <a:srgbClr val="1A5276"/>
                 </a:solidFill>
                 <a:latin typeface="Calibri"/>
               </a:defRPr>
@@ -8618,66 +8402,20 @@
               <a:rPr>
                 <a:latin typeface="Aptos Display" panose="020B0004020202020204" pitchFamily="34" charset="0"/>
               </a:rPr>
-              <a:t>10 complex queries — subqueries, EXISTS, window functions (RANK)</a:t>
-            </a:r>
-          </a:p>
-        </p:txBody>
-      </p:sp>
-      <p:sp>
-        <p:nvSpPr>
-          <p:cNvPr id="15" name="Rectangle 14"/>
-          <p:cNvSpPr/>
-          <p:nvPr/>
-        </p:nvSpPr>
-        <p:spPr>
-          <a:xfrm>
-            <a:off x="731520" y="4206240"/>
-            <a:ext cx="54864" cy="320040"/>
-          </a:xfrm>
-          <a:prstGeom prst="rect">
-            <a:avLst/>
-          </a:prstGeom>
-          <a:solidFill>
-            <a:srgbClr val="1A5276"/>
-          </a:solidFill>
-          <a:ln>
-            <a:noFill/>
-          </a:ln>
-        </p:spPr>
-        <p:style>
-          <a:lnRef idx="1">
-            <a:schemeClr val="accent1"/>
-          </a:lnRef>
-          <a:fillRef idx="3">
-            <a:schemeClr val="accent1"/>
-          </a:fillRef>
-          <a:effectRef idx="2">
-            <a:schemeClr val="accent1"/>
-          </a:effectRef>
-          <a:fontRef idx="minor">
-            <a:schemeClr val="lt1"/>
-          </a:fontRef>
-        </p:style>
-        <p:txBody>
-          <a:bodyPr rtlCol="0" anchor="ctr"/>
-          <a:lstStyle/>
-          <a:p>
-            <a:pPr algn="ctr"/>
-            <a:endParaRPr>
-              <a:latin typeface="Aptos Display" panose="020B0004020202020204" pitchFamily="34" charset="0"/>
-            </a:endParaRPr>
-          </a:p>
-        </p:txBody>
-      </p:sp>
-      <p:sp>
-        <p:nvSpPr>
-          <p:cNvPr id="16" name="TextBox 15"/>
+              <a:t>Database Population</a:t>
+            </a:r>
+          </a:p>
+        </p:txBody>
+      </p:sp>
+      <p:sp>
+        <p:nvSpPr>
+          <p:cNvPr id="21" name="TextBox 20"/>
           <p:cNvSpPr txBox="1"/>
           <p:nvPr/>
         </p:nvSpPr>
         <p:spPr>
           <a:xfrm>
-            <a:off x="1005840" y="4206240"/>
+            <a:off x="6583680" y="1919316"/>
             <a:ext cx="5029200" cy="292388"/>
           </a:xfrm>
           <a:prstGeom prst="rect">
@@ -8700,69 +8438,23 @@
               </a:defRPr>
             </a:pPr>
             <a:r>
-              <a:rPr>
-                <a:latin typeface="Aptos Display" panose="020B0004020202020204" pitchFamily="34" charset="0"/>
-              </a:rPr>
-              <a:t>16 triggers — auto-audit on all CRUD operations</a:t>
-            </a:r>
-          </a:p>
-        </p:txBody>
-      </p:sp>
-      <p:sp>
-        <p:nvSpPr>
-          <p:cNvPr id="17" name="Rectangle 16"/>
-          <p:cNvSpPr/>
-          <p:nvPr/>
-        </p:nvSpPr>
-        <p:spPr>
-          <a:xfrm>
-            <a:off x="731520" y="4663440"/>
-            <a:ext cx="54864" cy="320040"/>
-          </a:xfrm>
-          <a:prstGeom prst="rect">
-            <a:avLst/>
-          </a:prstGeom>
-          <a:solidFill>
-            <a:srgbClr val="1A5276"/>
-          </a:solidFill>
-          <a:ln>
-            <a:noFill/>
-          </a:ln>
-        </p:spPr>
-        <p:style>
-          <a:lnRef idx="1">
-            <a:schemeClr val="accent1"/>
-          </a:lnRef>
-          <a:fillRef idx="3">
-            <a:schemeClr val="accent1"/>
-          </a:fillRef>
-          <a:effectRef idx="2">
-            <a:schemeClr val="accent1"/>
-          </a:effectRef>
-          <a:fontRef idx="minor">
-            <a:schemeClr val="lt1"/>
-          </a:fontRef>
-        </p:style>
-        <p:txBody>
-          <a:bodyPr rtlCol="0" anchor="ctr"/>
-          <a:lstStyle/>
-          <a:p>
-            <a:pPr algn="ctr"/>
-            <a:endParaRPr>
-              <a:latin typeface="Aptos Display" panose="020B0004020202020204" pitchFamily="34" charset="0"/>
-            </a:endParaRPr>
-          </a:p>
-        </p:txBody>
-      </p:sp>
-      <p:sp>
-        <p:nvSpPr>
-          <p:cNvPr id="18" name="TextBox 17"/>
+              <a:rPr dirty="0">
+                <a:latin typeface="Aptos Display" panose="020B0004020202020204" pitchFamily="34" charset="0"/>
+              </a:rPr>
+              <a:t>18 tables, ~2,075 total records</a:t>
+            </a:r>
+          </a:p>
+        </p:txBody>
+      </p:sp>
+      <p:sp>
+        <p:nvSpPr>
+          <p:cNvPr id="23" name="TextBox 22"/>
           <p:cNvSpPr txBox="1"/>
           <p:nvPr/>
         </p:nvSpPr>
         <p:spPr>
           <a:xfrm>
-            <a:off x="1005840" y="4663440"/>
+            <a:off x="6583680" y="2376516"/>
             <a:ext cx="5029200" cy="292388"/>
           </a:xfrm>
           <a:prstGeom prst="rect">
@@ -8788,21 +8480,21 @@
               <a:rPr>
                 <a:latin typeface="Aptos Display" panose="020B0004020202020204" pitchFamily="34" charset="0"/>
               </a:rPr>
-              <a:t>All queries executable from docs/db_schema/queries.sql</a:t>
-            </a:r>
-          </a:p>
-        </p:txBody>
-      </p:sp>
-      <p:sp>
-        <p:nvSpPr>
-          <p:cNvPr id="19" name="TextBox 18"/>
+              <a:t>Section A: 10 direct INSERTs per table</a:t>
+            </a:r>
+          </a:p>
+        </p:txBody>
+      </p:sp>
+      <p:sp>
+        <p:nvSpPr>
+          <p:cNvPr id="25" name="TextBox 24"/>
           <p:cNvSpPr txBox="1"/>
           <p:nvPr/>
         </p:nvSpPr>
         <p:spPr>
           <a:xfrm>
-            <a:off x="6583680" y="1371600"/>
-            <a:ext cx="5029200" cy="430887"/>
+            <a:off x="6583680" y="2833716"/>
+            <a:ext cx="5029200" cy="292388"/>
           </a:xfrm>
           <a:prstGeom prst="rect">
             <a:avLst/>
@@ -8816,9 +8508,9 @@
           <a:lstStyle/>
           <a:p>
             <a:pPr algn="l">
-              <a:defRPr sz="2200" b="1">
-                <a:solidFill>
-                  <a:srgbClr val="1A5276"/>
+              <a:defRPr sz="1300" b="0">
+                <a:solidFill>
+                  <a:srgbClr val="2C3E50"/>
                 </a:solidFill>
                 <a:latin typeface="Calibri"/>
               </a:defRPr>
@@ -8827,66 +8519,20 @@
               <a:rPr>
                 <a:latin typeface="Aptos Display" panose="020B0004020202020204" pitchFamily="34" charset="0"/>
               </a:rPr>
-              <a:t>Database Population</a:t>
-            </a:r>
-          </a:p>
-        </p:txBody>
-      </p:sp>
-      <p:sp>
-        <p:nvSpPr>
-          <p:cNvPr id="20" name="Rectangle 19"/>
-          <p:cNvSpPr/>
-          <p:nvPr/>
-        </p:nvSpPr>
-        <p:spPr>
-          <a:xfrm>
-            <a:off x="6583680" y="1920240"/>
-            <a:ext cx="54864" cy="320040"/>
-          </a:xfrm>
-          <a:prstGeom prst="rect">
-            <a:avLst/>
-          </a:prstGeom>
-          <a:solidFill>
-            <a:srgbClr val="E74C3C"/>
-          </a:solidFill>
-          <a:ln>
-            <a:noFill/>
-          </a:ln>
-        </p:spPr>
-        <p:style>
-          <a:lnRef idx="1">
-            <a:schemeClr val="accent1"/>
-          </a:lnRef>
-          <a:fillRef idx="3">
-            <a:schemeClr val="accent1"/>
-          </a:fillRef>
-          <a:effectRef idx="2">
-            <a:schemeClr val="accent1"/>
-          </a:effectRef>
-          <a:fontRef idx="minor">
-            <a:schemeClr val="lt1"/>
-          </a:fontRef>
-        </p:style>
-        <p:txBody>
-          <a:bodyPr rtlCol="0" anchor="ctr"/>
-          <a:lstStyle/>
-          <a:p>
-            <a:pPr algn="ctr"/>
-            <a:endParaRPr>
-              <a:latin typeface="Aptos Display" panose="020B0004020202020204" pitchFamily="34" charset="0"/>
-            </a:endParaRPr>
-          </a:p>
-        </p:txBody>
-      </p:sp>
-      <p:sp>
-        <p:nvSpPr>
-          <p:cNvPr id="21" name="TextBox 20"/>
+              <a:t>Section B: 10 INSERT...SELECT data transfers</a:t>
+            </a:r>
+          </a:p>
+        </p:txBody>
+      </p:sp>
+      <p:sp>
+        <p:nvSpPr>
+          <p:cNvPr id="27" name="TextBox 26"/>
           <p:cNvSpPr txBox="1"/>
           <p:nvPr/>
         </p:nvSpPr>
         <p:spPr>
           <a:xfrm>
-            <a:off x="6858000" y="1920240"/>
+            <a:off x="6583680" y="3290916"/>
             <a:ext cx="5029200" cy="292388"/>
           </a:xfrm>
           <a:prstGeom prst="rect">
@@ -8912,66 +8558,20 @@
               <a:rPr>
                 <a:latin typeface="Aptos Display" panose="020B0004020202020204" pitchFamily="34" charset="0"/>
               </a:rPr>
-              <a:t>18 tables, ~2,075 total records</a:t>
-            </a:r>
-          </a:p>
-        </p:txBody>
-      </p:sp>
-      <p:sp>
-        <p:nvSpPr>
-          <p:cNvPr id="22" name="Rectangle 21"/>
-          <p:cNvSpPr/>
-          <p:nvPr/>
-        </p:nvSpPr>
-        <p:spPr>
-          <a:xfrm>
-            <a:off x="6583680" y="2377440"/>
-            <a:ext cx="54864" cy="320040"/>
-          </a:xfrm>
-          <a:prstGeom prst="rect">
-            <a:avLst/>
-          </a:prstGeom>
-          <a:solidFill>
-            <a:srgbClr val="E74C3C"/>
-          </a:solidFill>
-          <a:ln>
-            <a:noFill/>
-          </a:ln>
-        </p:spPr>
-        <p:style>
-          <a:lnRef idx="1">
-            <a:schemeClr val="accent1"/>
-          </a:lnRef>
-          <a:fillRef idx="3">
-            <a:schemeClr val="accent1"/>
-          </a:fillRef>
-          <a:effectRef idx="2">
-            <a:schemeClr val="accent1"/>
-          </a:effectRef>
-          <a:fontRef idx="minor">
-            <a:schemeClr val="lt1"/>
-          </a:fontRef>
-        </p:style>
-        <p:txBody>
-          <a:bodyPr rtlCol="0" anchor="ctr"/>
-          <a:lstStyle/>
-          <a:p>
-            <a:pPr algn="ctr"/>
-            <a:endParaRPr>
-              <a:latin typeface="Aptos Display" panose="020B0004020202020204" pitchFamily="34" charset="0"/>
-            </a:endParaRPr>
-          </a:p>
-        </p:txBody>
-      </p:sp>
-      <p:sp>
-        <p:nvSpPr>
-          <p:cNvPr id="23" name="TextBox 22"/>
+              <a:t>Section C: 100+ AI-generated records per table</a:t>
+            </a:r>
+          </a:p>
+        </p:txBody>
+      </p:sp>
+      <p:sp>
+        <p:nvSpPr>
+          <p:cNvPr id="29" name="TextBox 28"/>
           <p:cNvSpPr txBox="1"/>
           <p:nvPr/>
         </p:nvSpPr>
         <p:spPr>
           <a:xfrm>
-            <a:off x="6858000" y="2377440"/>
+            <a:off x="6583680" y="3748115"/>
             <a:ext cx="5029200" cy="292388"/>
           </a:xfrm>
           <a:prstGeom prst="rect">
@@ -8994,69 +8594,23 @@
               </a:defRPr>
             </a:pPr>
             <a:r>
-              <a:rPr>
-                <a:latin typeface="Aptos Display" panose="020B0004020202020204" pitchFamily="34" charset="0"/>
-              </a:rPr>
-              <a:t>Section A: 10 direct INSERTs per table</a:t>
-            </a:r>
-          </a:p>
-        </p:txBody>
-      </p:sp>
-      <p:sp>
-        <p:nvSpPr>
-          <p:cNvPr id="24" name="Rectangle 23"/>
-          <p:cNvSpPr/>
-          <p:nvPr/>
-        </p:nvSpPr>
-        <p:spPr>
-          <a:xfrm>
-            <a:off x="6583680" y="2834640"/>
-            <a:ext cx="54864" cy="320040"/>
-          </a:xfrm>
-          <a:prstGeom prst="rect">
-            <a:avLst/>
-          </a:prstGeom>
-          <a:solidFill>
-            <a:srgbClr val="E74C3C"/>
-          </a:solidFill>
-          <a:ln>
-            <a:noFill/>
-          </a:ln>
-        </p:spPr>
-        <p:style>
-          <a:lnRef idx="1">
-            <a:schemeClr val="accent1"/>
-          </a:lnRef>
-          <a:fillRef idx="3">
-            <a:schemeClr val="accent1"/>
-          </a:fillRef>
-          <a:effectRef idx="2">
-            <a:schemeClr val="accent1"/>
-          </a:effectRef>
-          <a:fontRef idx="minor">
-            <a:schemeClr val="lt1"/>
-          </a:fontRef>
-        </p:style>
-        <p:txBody>
-          <a:bodyPr rtlCol="0" anchor="ctr"/>
-          <a:lstStyle/>
-          <a:p>
-            <a:pPr algn="ctr"/>
-            <a:endParaRPr>
-              <a:latin typeface="Aptos Display" panose="020B0004020202020204" pitchFamily="34" charset="0"/>
-            </a:endParaRPr>
-          </a:p>
-        </p:txBody>
-      </p:sp>
-      <p:sp>
-        <p:nvSpPr>
-          <p:cNvPr id="25" name="TextBox 24"/>
+              <a:rPr dirty="0">
+                <a:latin typeface="Aptos Display" panose="020B0004020202020204" pitchFamily="34" charset="0"/>
+              </a:rPr>
+              <a:t>AI prompts documented in ai_prompts.md</a:t>
+            </a:r>
+          </a:p>
+        </p:txBody>
+      </p:sp>
+      <p:sp>
+        <p:nvSpPr>
+          <p:cNvPr id="31" name="TextBox 30"/>
           <p:cNvSpPr txBox="1"/>
           <p:nvPr/>
         </p:nvSpPr>
         <p:spPr>
           <a:xfrm>
-            <a:off x="6858000" y="2834640"/>
+            <a:off x="6583680" y="4205316"/>
             <a:ext cx="5029200" cy="292388"/>
           </a:xfrm>
           <a:prstGeom prst="rect">
@@ -9082,309 +8636,8 @@
               <a:rPr>
                 <a:latin typeface="Aptos Display" panose="020B0004020202020204" pitchFamily="34" charset="0"/>
               </a:rPr>
-              <a:t>Section B: 10 INSERT...SELECT data transfers</a:t>
-            </a:r>
-          </a:p>
-        </p:txBody>
-      </p:sp>
-      <p:sp>
-        <p:nvSpPr>
-          <p:cNvPr id="26" name="Rectangle 25"/>
-          <p:cNvSpPr/>
-          <p:nvPr/>
-        </p:nvSpPr>
-        <p:spPr>
-          <a:xfrm>
-            <a:off x="6583680" y="3291840"/>
-            <a:ext cx="54864" cy="320040"/>
-          </a:xfrm>
-          <a:prstGeom prst="rect">
-            <a:avLst/>
-          </a:prstGeom>
-          <a:solidFill>
-            <a:srgbClr val="E74C3C"/>
-          </a:solidFill>
-          <a:ln>
-            <a:noFill/>
-          </a:ln>
-        </p:spPr>
-        <p:style>
-          <a:lnRef idx="1">
-            <a:schemeClr val="accent1"/>
-          </a:lnRef>
-          <a:fillRef idx="3">
-            <a:schemeClr val="accent1"/>
-          </a:fillRef>
-          <a:effectRef idx="2">
-            <a:schemeClr val="accent1"/>
-          </a:effectRef>
-          <a:fontRef idx="minor">
-            <a:schemeClr val="lt1"/>
-          </a:fontRef>
-        </p:style>
-        <p:txBody>
-          <a:bodyPr rtlCol="0" anchor="ctr"/>
-          <a:lstStyle/>
-          <a:p>
-            <a:pPr algn="ctr"/>
-            <a:endParaRPr>
-              <a:latin typeface="Aptos Display" panose="020B0004020202020204" pitchFamily="34" charset="0"/>
-            </a:endParaRPr>
-          </a:p>
-        </p:txBody>
-      </p:sp>
-      <p:sp>
-        <p:nvSpPr>
-          <p:cNvPr id="27" name="TextBox 26"/>
-          <p:cNvSpPr txBox="1"/>
-          <p:nvPr/>
-        </p:nvSpPr>
-        <p:spPr>
-          <a:xfrm>
-            <a:off x="6858000" y="3291840"/>
-            <a:ext cx="5029200" cy="292388"/>
-          </a:xfrm>
-          <a:prstGeom prst="rect">
-            <a:avLst/>
-          </a:prstGeom>
-          <a:noFill/>
-        </p:spPr>
-        <p:txBody>
-          <a:bodyPr wrap="square">
-            <a:spAutoFit/>
-          </a:bodyPr>
-          <a:lstStyle/>
-          <a:p>
-            <a:pPr algn="l">
-              <a:defRPr sz="1300" b="0">
-                <a:solidFill>
-                  <a:srgbClr val="2C3E50"/>
-                </a:solidFill>
-                <a:latin typeface="Calibri"/>
-              </a:defRPr>
-            </a:pPr>
-            <a:r>
-              <a:rPr>
-                <a:latin typeface="Aptos Display" panose="020B0004020202020204" pitchFamily="34" charset="0"/>
-              </a:rPr>
-              <a:t>Section C: 100+ AI-generated records per table</a:t>
-            </a:r>
-          </a:p>
-        </p:txBody>
-      </p:sp>
-      <p:sp>
-        <p:nvSpPr>
-          <p:cNvPr id="28" name="Rectangle 27"/>
-          <p:cNvSpPr/>
-          <p:nvPr/>
-        </p:nvSpPr>
-        <p:spPr>
-          <a:xfrm>
-            <a:off x="6583680" y="3749039"/>
-            <a:ext cx="54864" cy="320040"/>
-          </a:xfrm>
-          <a:prstGeom prst="rect">
-            <a:avLst/>
-          </a:prstGeom>
-          <a:solidFill>
-            <a:srgbClr val="E74C3C"/>
-          </a:solidFill>
-          <a:ln>
-            <a:noFill/>
-          </a:ln>
-        </p:spPr>
-        <p:style>
-          <a:lnRef idx="1">
-            <a:schemeClr val="accent1"/>
-          </a:lnRef>
-          <a:fillRef idx="3">
-            <a:schemeClr val="accent1"/>
-          </a:fillRef>
-          <a:effectRef idx="2">
-            <a:schemeClr val="accent1"/>
-          </a:effectRef>
-          <a:fontRef idx="minor">
-            <a:schemeClr val="lt1"/>
-          </a:fontRef>
-        </p:style>
-        <p:txBody>
-          <a:bodyPr rtlCol="0" anchor="ctr"/>
-          <a:lstStyle/>
-          <a:p>
-            <a:pPr algn="ctr"/>
-            <a:endParaRPr>
-              <a:latin typeface="Aptos Display" panose="020B0004020202020204" pitchFamily="34" charset="0"/>
-            </a:endParaRPr>
-          </a:p>
-        </p:txBody>
-      </p:sp>
-      <p:sp>
-        <p:nvSpPr>
-          <p:cNvPr id="29" name="TextBox 28"/>
-          <p:cNvSpPr txBox="1"/>
-          <p:nvPr/>
-        </p:nvSpPr>
-        <p:spPr>
-          <a:xfrm>
-            <a:off x="6858000" y="3749039"/>
-            <a:ext cx="5029200" cy="292388"/>
-          </a:xfrm>
-          <a:prstGeom prst="rect">
-            <a:avLst/>
-          </a:prstGeom>
-          <a:noFill/>
-        </p:spPr>
-        <p:txBody>
-          <a:bodyPr wrap="square">
-            <a:spAutoFit/>
-          </a:bodyPr>
-          <a:lstStyle/>
-          <a:p>
-            <a:pPr algn="l">
-              <a:defRPr sz="1300" b="0">
-                <a:solidFill>
-                  <a:srgbClr val="2C3E50"/>
-                </a:solidFill>
-                <a:latin typeface="Calibri"/>
-              </a:defRPr>
-            </a:pPr>
-            <a:r>
-              <a:rPr>
-                <a:latin typeface="Aptos Display" panose="020B0004020202020204" pitchFamily="34" charset="0"/>
-              </a:rPr>
-              <a:t>AI prompts documented in ai_prompts.md</a:t>
-            </a:r>
-          </a:p>
-        </p:txBody>
-      </p:sp>
-      <p:sp>
-        <p:nvSpPr>
-          <p:cNvPr id="30" name="Rectangle 29"/>
-          <p:cNvSpPr/>
-          <p:nvPr/>
-        </p:nvSpPr>
-        <p:spPr>
-          <a:xfrm>
-            <a:off x="6583680" y="4206240"/>
-            <a:ext cx="54864" cy="320040"/>
-          </a:xfrm>
-          <a:prstGeom prst="rect">
-            <a:avLst/>
-          </a:prstGeom>
-          <a:solidFill>
-            <a:srgbClr val="E74C3C"/>
-          </a:solidFill>
-          <a:ln>
-            <a:noFill/>
-          </a:ln>
-        </p:spPr>
-        <p:style>
-          <a:lnRef idx="1">
-            <a:schemeClr val="accent1"/>
-          </a:lnRef>
-          <a:fillRef idx="3">
-            <a:schemeClr val="accent1"/>
-          </a:fillRef>
-          <a:effectRef idx="2">
-            <a:schemeClr val="accent1"/>
-          </a:effectRef>
-          <a:fontRef idx="minor">
-            <a:schemeClr val="lt1"/>
-          </a:fontRef>
-        </p:style>
-        <p:txBody>
-          <a:bodyPr rtlCol="0" anchor="ctr"/>
-          <a:lstStyle/>
-          <a:p>
-            <a:pPr algn="ctr"/>
-            <a:endParaRPr>
-              <a:latin typeface="Aptos Display" panose="020B0004020202020204" pitchFamily="34" charset="0"/>
-            </a:endParaRPr>
-          </a:p>
-        </p:txBody>
-      </p:sp>
-      <p:sp>
-        <p:nvSpPr>
-          <p:cNvPr id="31" name="TextBox 30"/>
-          <p:cNvSpPr txBox="1"/>
-          <p:nvPr/>
-        </p:nvSpPr>
-        <p:spPr>
-          <a:xfrm>
-            <a:off x="6858000" y="4206240"/>
-            <a:ext cx="5029200" cy="292388"/>
-          </a:xfrm>
-          <a:prstGeom prst="rect">
-            <a:avLst/>
-          </a:prstGeom>
-          <a:noFill/>
-        </p:spPr>
-        <p:txBody>
-          <a:bodyPr wrap="square">
-            <a:spAutoFit/>
-          </a:bodyPr>
-          <a:lstStyle/>
-          <a:p>
-            <a:pPr algn="l">
-              <a:defRPr sz="1300" b="0">
-                <a:solidFill>
-                  <a:srgbClr val="2C3E50"/>
-                </a:solidFill>
-                <a:latin typeface="Calibri"/>
-              </a:defRPr>
-            </a:pPr>
-            <a:r>
-              <a:rPr>
-                <a:latin typeface="Aptos Display" panose="020B0004020202020204" pitchFamily="34" charset="0"/>
-              </a:rPr>
               <a:t>4 data entry methods: Visual, SQL, Transfer, AI</a:t>
             </a:r>
-          </a:p>
-        </p:txBody>
-      </p:sp>
-      <p:sp>
-        <p:nvSpPr>
-          <p:cNvPr id="32" name="Rectangle 31"/>
-          <p:cNvSpPr/>
-          <p:nvPr/>
-        </p:nvSpPr>
-        <p:spPr>
-          <a:xfrm>
-            <a:off x="6583680" y="4663440"/>
-            <a:ext cx="54864" cy="320040"/>
-          </a:xfrm>
-          <a:prstGeom prst="rect">
-            <a:avLst/>
-          </a:prstGeom>
-          <a:solidFill>
-            <a:srgbClr val="E74C3C"/>
-          </a:solidFill>
-          <a:ln>
-            <a:noFill/>
-          </a:ln>
-        </p:spPr>
-        <p:style>
-          <a:lnRef idx="1">
-            <a:schemeClr val="accent1"/>
-          </a:lnRef>
-          <a:fillRef idx="3">
-            <a:schemeClr val="accent1"/>
-          </a:fillRef>
-          <a:effectRef idx="2">
-            <a:schemeClr val="accent1"/>
-          </a:effectRef>
-          <a:fontRef idx="minor">
-            <a:schemeClr val="lt1"/>
-          </a:fontRef>
-        </p:style>
-        <p:txBody>
-          <a:bodyPr rtlCol="0" anchor="ctr"/>
-          <a:lstStyle/>
-          <a:p>
-            <a:pPr algn="ctr"/>
-            <a:endParaRPr>
-              <a:latin typeface="Aptos Display" panose="020B0004020202020204" pitchFamily="34" charset="0"/>
-            </a:endParaRPr>
           </a:p>
         </p:txBody>
       </p:sp>
@@ -9396,7 +8649,7 @@
         </p:nvSpPr>
         <p:spPr>
           <a:xfrm>
-            <a:off x="6858000" y="4663440"/>
+            <a:off x="6583680" y="4662516"/>
             <a:ext cx="5029200" cy="292388"/>
           </a:xfrm>
           <a:prstGeom prst="rect">
@@ -9616,59 +8869,13 @@
       </p:sp>
       <p:sp>
         <p:nvSpPr>
-          <p:cNvPr id="5" name="Rectangle 4"/>
-          <p:cNvSpPr/>
-          <p:nvPr/>
-        </p:nvSpPr>
-        <p:spPr>
-          <a:xfrm>
-            <a:off x="731520" y="1920240"/>
-            <a:ext cx="73152" cy="320040"/>
-          </a:xfrm>
-          <a:prstGeom prst="rect">
-            <a:avLst/>
-          </a:prstGeom>
-          <a:solidFill>
-            <a:srgbClr val="27AE60"/>
-          </a:solidFill>
-          <a:ln>
-            <a:noFill/>
-          </a:ln>
-        </p:spPr>
-        <p:style>
-          <a:lnRef idx="1">
-            <a:schemeClr val="accent1"/>
-          </a:lnRef>
-          <a:fillRef idx="3">
-            <a:schemeClr val="accent1"/>
-          </a:fillRef>
-          <a:effectRef idx="2">
-            <a:schemeClr val="accent1"/>
-          </a:effectRef>
-          <a:fontRef idx="minor">
-            <a:schemeClr val="lt1"/>
-          </a:fontRef>
-        </p:style>
-        <p:txBody>
-          <a:bodyPr rtlCol="0" anchor="ctr"/>
-          <a:lstStyle/>
-          <a:p>
-            <a:pPr algn="ctr"/>
-            <a:endParaRPr>
-              <a:latin typeface="Aptos Display" panose="020B0004020202020204" pitchFamily="34" charset="0"/>
-            </a:endParaRPr>
-          </a:p>
-        </p:txBody>
-      </p:sp>
-      <p:sp>
-        <p:nvSpPr>
           <p:cNvPr id="6" name="TextBox 5"/>
           <p:cNvSpPr txBox="1"/>
           <p:nvPr/>
         </p:nvSpPr>
         <p:spPr>
           <a:xfrm>
-            <a:off x="1097280" y="1920240"/>
+            <a:off x="731520" y="1920240"/>
             <a:ext cx="10058400" cy="323165"/>
           </a:xfrm>
           <a:prstGeom prst="rect">
@@ -9691,57 +8898,11 @@
               </a:defRPr>
             </a:pPr>
             <a:r>
-              <a:rPr>
+              <a:rPr dirty="0">
                 <a:latin typeface="Aptos Display" panose="020B0004020202020204" pitchFamily="34" charset="0"/>
               </a:rPr>
               <a:t>Fully functional 18-entity database normalized to 3NF with referential integrity</a:t>
             </a:r>
-          </a:p>
-        </p:txBody>
-      </p:sp>
-      <p:sp>
-        <p:nvSpPr>
-          <p:cNvPr id="7" name="Rectangle 6"/>
-          <p:cNvSpPr/>
-          <p:nvPr/>
-        </p:nvSpPr>
-        <p:spPr>
-          <a:xfrm>
-            <a:off x="731520" y="2423160"/>
-            <a:ext cx="73152" cy="320040"/>
-          </a:xfrm>
-          <a:prstGeom prst="rect">
-            <a:avLst/>
-          </a:prstGeom>
-          <a:solidFill>
-            <a:srgbClr val="27AE60"/>
-          </a:solidFill>
-          <a:ln>
-            <a:noFill/>
-          </a:ln>
-        </p:spPr>
-        <p:style>
-          <a:lnRef idx="1">
-            <a:schemeClr val="accent1"/>
-          </a:lnRef>
-          <a:fillRef idx="3">
-            <a:schemeClr val="accent1"/>
-          </a:fillRef>
-          <a:effectRef idx="2">
-            <a:schemeClr val="accent1"/>
-          </a:effectRef>
-          <a:fontRef idx="minor">
-            <a:schemeClr val="lt1"/>
-          </a:fontRef>
-        </p:style>
-        <p:txBody>
-          <a:bodyPr rtlCol="0" anchor="ctr"/>
-          <a:lstStyle/>
-          <a:p>
-            <a:pPr algn="ctr"/>
-            <a:endParaRPr>
-              <a:latin typeface="Aptos Display" panose="020B0004020202020204" pitchFamily="34" charset="0"/>
-            </a:endParaRPr>
           </a:p>
         </p:txBody>
       </p:sp>
@@ -9753,7 +8914,7 @@
         </p:nvSpPr>
         <p:spPr>
           <a:xfrm>
-            <a:off x="1097280" y="2423160"/>
+            <a:off x="731520" y="2423160"/>
             <a:ext cx="10058400" cy="323165"/>
           </a:xfrm>
           <a:prstGeom prst="rect">
@@ -9786,59 +8947,13 @@
       </p:sp>
       <p:sp>
         <p:nvSpPr>
-          <p:cNvPr id="9" name="Rectangle 8"/>
-          <p:cNvSpPr/>
-          <p:nvPr/>
-        </p:nvSpPr>
-        <p:spPr>
-          <a:xfrm>
-            <a:off x="731520" y="2926080"/>
-            <a:ext cx="73152" cy="320040"/>
-          </a:xfrm>
-          <a:prstGeom prst="rect">
-            <a:avLst/>
-          </a:prstGeom>
-          <a:solidFill>
-            <a:srgbClr val="27AE60"/>
-          </a:solidFill>
-          <a:ln>
-            <a:noFill/>
-          </a:ln>
-        </p:spPr>
-        <p:style>
-          <a:lnRef idx="1">
-            <a:schemeClr val="accent1"/>
-          </a:lnRef>
-          <a:fillRef idx="3">
-            <a:schemeClr val="accent1"/>
-          </a:fillRef>
-          <a:effectRef idx="2">
-            <a:schemeClr val="accent1"/>
-          </a:effectRef>
-          <a:fontRef idx="minor">
-            <a:schemeClr val="lt1"/>
-          </a:fontRef>
-        </p:style>
-        <p:txBody>
-          <a:bodyPr rtlCol="0" anchor="ctr"/>
-          <a:lstStyle/>
-          <a:p>
-            <a:pPr algn="ctr"/>
-            <a:endParaRPr>
-              <a:latin typeface="Aptos Display" panose="020B0004020202020204" pitchFamily="34" charset="0"/>
-            </a:endParaRPr>
-          </a:p>
-        </p:txBody>
-      </p:sp>
-      <p:sp>
-        <p:nvSpPr>
           <p:cNvPr id="10" name="TextBox 9"/>
           <p:cNvSpPr txBox="1"/>
           <p:nvPr/>
         </p:nvSpPr>
         <p:spPr>
           <a:xfrm>
-            <a:off x="1097280" y="2926080"/>
+            <a:off x="731520" y="2926080"/>
             <a:ext cx="10058400" cy="323165"/>
           </a:xfrm>
           <a:prstGeom prst="rect">
@@ -9871,59 +8986,13 @@
       </p:sp>
       <p:sp>
         <p:nvSpPr>
-          <p:cNvPr id="11" name="Rectangle 10"/>
-          <p:cNvSpPr/>
-          <p:nvPr/>
-        </p:nvSpPr>
-        <p:spPr>
-          <a:xfrm>
-            <a:off x="731520" y="3429000"/>
-            <a:ext cx="73152" cy="320040"/>
-          </a:xfrm>
-          <a:prstGeom prst="rect">
-            <a:avLst/>
-          </a:prstGeom>
-          <a:solidFill>
-            <a:srgbClr val="27AE60"/>
-          </a:solidFill>
-          <a:ln>
-            <a:noFill/>
-          </a:ln>
-        </p:spPr>
-        <p:style>
-          <a:lnRef idx="1">
-            <a:schemeClr val="accent1"/>
-          </a:lnRef>
-          <a:fillRef idx="3">
-            <a:schemeClr val="accent1"/>
-          </a:fillRef>
-          <a:effectRef idx="2">
-            <a:schemeClr val="accent1"/>
-          </a:effectRef>
-          <a:fontRef idx="minor">
-            <a:schemeClr val="lt1"/>
-          </a:fontRef>
-        </p:style>
-        <p:txBody>
-          <a:bodyPr rtlCol="0" anchor="ctr"/>
-          <a:lstStyle/>
-          <a:p>
-            <a:pPr algn="ctr"/>
-            <a:endParaRPr>
-              <a:latin typeface="Aptos Display" panose="020B0004020202020204" pitchFamily="34" charset="0"/>
-            </a:endParaRPr>
-          </a:p>
-        </p:txBody>
-      </p:sp>
-      <p:sp>
-        <p:nvSpPr>
           <p:cNvPr id="12" name="TextBox 11"/>
           <p:cNvSpPr txBox="1"/>
           <p:nvPr/>
         </p:nvSpPr>
         <p:spPr>
           <a:xfrm>
-            <a:off x="1097280" y="3429000"/>
+            <a:off x="731520" y="3429000"/>
             <a:ext cx="10058400" cy="323165"/>
           </a:xfrm>
           <a:prstGeom prst="rect">
@@ -9956,59 +9025,13 @@
       </p:sp>
       <p:sp>
         <p:nvSpPr>
-          <p:cNvPr id="13" name="Rectangle 12"/>
-          <p:cNvSpPr/>
-          <p:nvPr/>
-        </p:nvSpPr>
-        <p:spPr>
-          <a:xfrm>
-            <a:off x="731520" y="3931920"/>
-            <a:ext cx="73152" cy="320040"/>
-          </a:xfrm>
-          <a:prstGeom prst="rect">
-            <a:avLst/>
-          </a:prstGeom>
-          <a:solidFill>
-            <a:srgbClr val="27AE60"/>
-          </a:solidFill>
-          <a:ln>
-            <a:noFill/>
-          </a:ln>
-        </p:spPr>
-        <p:style>
-          <a:lnRef idx="1">
-            <a:schemeClr val="accent1"/>
-          </a:lnRef>
-          <a:fillRef idx="3">
-            <a:schemeClr val="accent1"/>
-          </a:fillRef>
-          <a:effectRef idx="2">
-            <a:schemeClr val="accent1"/>
-          </a:effectRef>
-          <a:fontRef idx="minor">
-            <a:schemeClr val="lt1"/>
-          </a:fontRef>
-        </p:style>
-        <p:txBody>
-          <a:bodyPr rtlCol="0" anchor="ctr"/>
-          <a:lstStyle/>
-          <a:p>
-            <a:pPr algn="ctr"/>
-            <a:endParaRPr>
-              <a:latin typeface="Aptos Display" panose="020B0004020202020204" pitchFamily="34" charset="0"/>
-            </a:endParaRPr>
-          </a:p>
-        </p:txBody>
-      </p:sp>
-      <p:sp>
-        <p:nvSpPr>
           <p:cNvPr id="14" name="TextBox 13"/>
           <p:cNvSpPr txBox="1"/>
           <p:nvPr/>
         </p:nvSpPr>
         <p:spPr>
           <a:xfrm>
-            <a:off x="1097280" y="3931920"/>
+            <a:off x="731520" y="3931920"/>
             <a:ext cx="10058400" cy="323165"/>
           </a:xfrm>
           <a:prstGeom prst="rect">
@@ -10041,59 +9064,13 @@
       </p:sp>
       <p:sp>
         <p:nvSpPr>
-          <p:cNvPr id="15" name="Rectangle 14"/>
-          <p:cNvSpPr/>
-          <p:nvPr/>
-        </p:nvSpPr>
-        <p:spPr>
-          <a:xfrm>
-            <a:off x="731520" y="4434840"/>
-            <a:ext cx="73152" cy="320040"/>
-          </a:xfrm>
-          <a:prstGeom prst="rect">
-            <a:avLst/>
-          </a:prstGeom>
-          <a:solidFill>
-            <a:srgbClr val="27AE60"/>
-          </a:solidFill>
-          <a:ln>
-            <a:noFill/>
-          </a:ln>
-        </p:spPr>
-        <p:style>
-          <a:lnRef idx="1">
-            <a:schemeClr val="accent1"/>
-          </a:lnRef>
-          <a:fillRef idx="3">
-            <a:schemeClr val="accent1"/>
-          </a:fillRef>
-          <a:effectRef idx="2">
-            <a:schemeClr val="accent1"/>
-          </a:effectRef>
-          <a:fontRef idx="minor">
-            <a:schemeClr val="lt1"/>
-          </a:fontRef>
-        </p:style>
-        <p:txBody>
-          <a:bodyPr rtlCol="0" anchor="ctr"/>
-          <a:lstStyle/>
-          <a:p>
-            <a:pPr algn="ctr"/>
-            <a:endParaRPr>
-              <a:latin typeface="Aptos Display" panose="020B0004020202020204" pitchFamily="34" charset="0"/>
-            </a:endParaRPr>
-          </a:p>
-        </p:txBody>
-      </p:sp>
-      <p:sp>
-        <p:nvSpPr>
           <p:cNvPr id="16" name="TextBox 15"/>
           <p:cNvSpPr txBox="1"/>
           <p:nvPr/>
         </p:nvSpPr>
         <p:spPr>
           <a:xfrm>
-            <a:off x="1097280" y="4434840"/>
+            <a:off x="731520" y="4434840"/>
             <a:ext cx="10058400" cy="323165"/>
           </a:xfrm>
           <a:prstGeom prst="rect">
@@ -10311,7 +9288,7 @@
               </a:defRPr>
             </a:pPr>
             <a:r>
-              <a:rPr>
+              <a:rPr dirty="0">
                 <a:latin typeface="Aptos Display" panose="020B0004020202020204" pitchFamily="34" charset="0"/>
               </a:rPr>
               <a:t>4. Graphical reporting dashboard with charts</a:t>

</xml_diff>